<commit_message>
6-slide deck: ALS audience slide and how-to-use slide; drop latency stat
Co-Authored-By: Claude Opus 5.5 <noreply@anthropic.com>
</commit_message>
<xml_diff>
--- a/docs/deck/final/Still_Here_6.pptx
+++ b/docs/deck/final/Still_Here_6.pptx
@@ -112,7 +112,7 @@
   <p:extLst>
     <p:ext uri="{521415D9-36F7-43E2-AB2F-B90AF26B5E84}">
       <p14:sectionLst xmlns:p14="http://schemas.microsoft.com/office/powerpoint/2010/main">
-        <p14:section name="Pitch" id="{eeae0af9-8a91-18eb-55a1-479e0f8c9008}">
+        <p14:section name="Pitch" id="{41d728f4-7ff8-94bf-d7d4-2fc6fc28df96}">
           <p14:sldIdLst>
             <p14:sldId id="256"/>
             <p14:sldId id="257"/>
@@ -614,7 +614,7 @@
           <a:p>
             <a:r>
               <a:rPr lang="en-US" dirty="0"/>
-              <a:t>Imagine a friend asks, "Are you coming to dinner tonight?" and by the time you spell out your answer, everyone has moved on. More than five million people in the U.S. are estimated to be unable to rely on speech alone, and most people with ALS lose their speech. Dedicated eye-gaze devices have cost over ten thousand dollars.</a:t>
+              <a:t>Imagine a friend asks, "Are you coming to dinner tonight?" and by the time you spell out an answer, everyone has moved on. We built for ALS first because most people with ALS lose their speech while their thinking often stays intact, and that is exactly what Still Here needs. The same face controls can also help people with locked-in syndrome, cerebral palsy, high spinal cord injury, and patients who cannot speak for a while, like after intubation.</a:t>
             </a:r>
             <a:endParaRPr lang="en-US" dirty="0"/>
           </a:p>
@@ -790,7 +790,7 @@
           <a:p>
             <a:r>
               <a:rPr lang="en-US" dirty="0"/>
-              <a:t>Here is the dinner question on the iPad. Two likely replies appear, and one long blink speaks the highlighted one. If neither fits, Other ways to answer lets the person pick a direction instead. Nothing is spoken unless the person chooses it.</a:t>
+              <a:t>There is no touch screen tapping and no eye tracker. Raising your eyebrows moves to the next option, keeping them up keeps moving, dropping your jaw goes back, and a long blink chooses and speaks. A one-minute calibration learns each person's face, and the partner simply talks.</a:t>
             </a:r>
             <a:endParaRPr lang="en-US" dirty="0"/>
           </a:p>
@@ -878,7 +878,7 @@
           <a:p>
             <a:r>
               <a:rPr lang="en-US" dirty="0"/>
-              <a:t>Face tracking runs on the iPad, so camera frames stay on the device by design, and a short calibration learns each person's face and blinks. Our server keeps the API keys private and calls OpenAI for replies and ElevenLabs for the voice. Learning is off by default and only keeps preferences the person approves.</a:t>
+              <a:t>Here is the dinner question on the iPad. Two likely replies appear, and one long blink speaks the highlighted one. If neither fits, Other ways to answer lets the person pick a direction instead. Nothing is spoken unless the person chooses it.</a:t>
             </a:r>
             <a:endParaRPr lang="en-US" dirty="0"/>
           </a:p>
@@ -966,7 +966,7 @@
           <a:p>
             <a:r>
               <a:rPr lang="en-US" dirty="0"/>
-              <a:t>From the partner finishing to suggestions on screen takes a median of 3.8 seconds, measured from a Mac with synthetic speech. Next, we want to test with people with ALS, bring it to phones and offline use, and add a personal voice with consent. Your words, your choice. Thank you.</a:t>
+              <a:t>Face tracking runs on the iPad, so camera frames stay on the device by design, and a short calibration learns each person's face. Our server keeps the API keys private and calls OpenAI for replies and ElevenLabs for the voice, and learning is off by default and keeps only what the person approves. Next, we want to test with people with ALS, bring it to phones and offline use, and add a personal voice. Your words, your choice. Thank you.</a:t>
             </a:r>
             <a:endParaRPr lang="en-US" dirty="0"/>
           </a:p>
@@ -2173,7 +2173,7 @@
                   <a:schemeClr val="tx1"/>
                 </a:solidFill>
               </a:rPr>
-              <a:t>The conversation moves on without them</a:t>
+              <a:t>Built for people living with ALS</a:t>
             </a:r>
             <a:endParaRPr lang="en-US" sz="3200" dirty="0"/>
           </a:p>
@@ -2181,18 +2181,18 @@
       </p:sp>
       <p:sp>
         <p:nvSpPr>
-          <p:cNvPr id="3" name="card"/>
+          <p:cNvPr id="3" name="ALS card"/>
           <p:cNvSpPr/>
           <p:nvPr/>
         </p:nvSpPr>
         <p:spPr>
           <a:xfrm>
-            <a:off x="457200" y="1280160"/>
-            <a:ext cx="2651760" cy="2468880"/>
+            <a:off x="457200" y="1143000"/>
+            <a:ext cx="4023360" cy="2514600"/>
           </a:xfrm>
           <a:prstGeom prst="roundRect">
             <a:avLst>
-              <a:gd name="adj" fmla="val 4444"/>
+              <a:gd name="adj" fmla="val 4364"/>
             </a:avLst>
           </a:prstGeom>
           <a:solidFill>
@@ -2221,8 +2221,8 @@
         </p:nvSpPr>
         <p:spPr>
           <a:xfrm>
-            <a:off x="640080" y="1508760"/>
-            <a:ext cx="2286000" cy="1051560"/>
+            <a:off x="685800" y="1298448"/>
+            <a:ext cx="3566160" cy="365760"/>
           </a:xfrm>
           <a:prstGeom prst="rect">
             <a:avLst/>
@@ -2234,18 +2234,18 @@
           <a:bodyPr wrap="square" lIns="0" tIns="0" rIns="0" bIns="0" rtlCol="0" anchor="ctr"/>
           <a:lstStyle/>
           <a:p>
-            <a:pPr algn="ctr" indent="0" marL="0">
+            <a:pPr indent="0" marL="0">
               <a:buNone/>
             </a:pPr>
             <a:r>
-              <a:rPr lang="en-US" sz="4800" b="1" dirty="0">
+              <a:rPr lang="en-US" sz="2000" b="1" dirty="0">
                 <a:solidFill>
                   <a:srgbClr val="0B5D46"/>
                 </a:solidFill>
               </a:rPr>
-              <a:t>5M+</a:t>
+              <a:t>What is ALS?</a:t>
             </a:r>
-            <a:endParaRPr lang="en-US" sz="4800" dirty="0"/>
+            <a:endParaRPr lang="en-US" sz="2000" dirty="0"/>
           </a:p>
         </p:txBody>
       </p:sp>
@@ -2257,8 +2257,8 @@
         </p:nvSpPr>
         <p:spPr>
           <a:xfrm>
-            <a:off x="640080" y="2697480"/>
-            <a:ext cx="2286000" cy="822960"/>
+            <a:off x="685800" y="1737360"/>
+            <a:ext cx="3566160" cy="1143000"/>
           </a:xfrm>
           <a:prstGeom prst="rect">
             <a:avLst/>
@@ -2270,35 +2270,94 @@
           <a:bodyPr wrap="square" lIns="0" tIns="0" rIns="0" bIns="0" rtlCol="0" anchor="t"/>
           <a:lstStyle/>
           <a:p>
-            <a:pPr algn="ctr" indent="0" marL="0">
+            <a:pPr indent="0" marL="0">
               <a:buNone/>
             </a:pPr>
             <a:r>
-              <a:rPr lang="en-US" sz="1800" dirty="0">
-                <a:solidFill>
-                  <a:srgbClr val="464B53"/>
+              <a:rPr lang="en-US" sz="1500" dirty="0">
+                <a:solidFill>
+                  <a:srgbClr val="121417"/>
                 </a:solidFill>
               </a:rPr>
-              <a:t>Americans can't rely on speech¹</a:t>
+              <a:t>A progressive disease that destroys the nerve cells controlling muscles. People lose movement, speech, and breathing. Thinking often stays intact.¹</a:t>
             </a:r>
-            <a:endParaRPr lang="en-US" sz="1800" dirty="0"/>
-          </a:p>
-        </p:txBody>
-      </p:sp>
-      <p:sp>
-        <p:nvSpPr>
-          <p:cNvPr id="6" name="card"/>
+            <a:endParaRPr lang="en-US" sz="1500" dirty="0"/>
+          </a:p>
+        </p:txBody>
+      </p:sp>
+      <p:sp>
+        <p:nvSpPr>
+          <p:cNvPr id="6" name="Shape 4"/>
           <p:cNvSpPr/>
           <p:nvPr/>
         </p:nvSpPr>
         <p:spPr>
           <a:xfrm>
-            <a:off x="3246120" y="1280160"/>
-            <a:ext cx="2651760" cy="2468880"/>
+            <a:off x="685800" y="2971800"/>
+            <a:ext cx="3566160" cy="0"/>
+          </a:xfrm>
+          <a:prstGeom prst="line">
+            <a:avLst/>
+          </a:prstGeom>
+          <a:noFill/>
+          <a:ln w="9525">
+            <a:solidFill>
+              <a:srgbClr val="D9DCE0"/>
+            </a:solidFill>
+            <a:prstDash val="solid"/>
+          </a:ln>
+        </p:spPr>
+      </p:sp>
+      <p:sp>
+        <p:nvSpPr>
+          <p:cNvPr id="7" name="Text 5"/>
+          <p:cNvSpPr txBox="1"/>
+          <p:nvPr/>
+        </p:nvSpPr>
+        <p:spPr>
+          <a:xfrm>
+            <a:off x="685800" y="3035808"/>
+            <a:ext cx="3566160" cy="502920"/>
+          </a:xfrm>
+          <a:prstGeom prst="rect">
+            <a:avLst/>
+          </a:prstGeom>
+          <a:noFill/>
+          <a:ln/>
+        </p:spPr>
+        <p:txBody>
+          <a:bodyPr wrap="square" lIns="0" tIns="0" rIns="0" bIns="0" rtlCol="0" anchor="ctr"/>
+          <a:lstStyle/>
+          <a:p>
+            <a:pPr indent="0" marL="0">
+              <a:buNone/>
+            </a:pPr>
+            <a:r>
+              <a:rPr lang="en-US" sz="1600" b="1" dirty="0">
+                <a:solidFill>
+                  <a:srgbClr val="0B5D46"/>
+                </a:solidFill>
+              </a:rPr>
+              <a:t>Most people with ALS lose their speech.²</a:t>
+            </a:r>
+            <a:endParaRPr lang="en-US" sz="1600" dirty="0"/>
+          </a:p>
+        </p:txBody>
+      </p:sp>
+      <p:sp>
+        <p:nvSpPr>
+          <p:cNvPr id="8" name="also helps card"/>
+          <p:cNvSpPr/>
+          <p:nvPr/>
+        </p:nvSpPr>
+        <p:spPr>
+          <a:xfrm>
+            <a:off x="4663440" y="1143000"/>
+            <a:ext cx="4023360" cy="2514600"/>
           </a:xfrm>
           <a:prstGeom prst="roundRect">
             <a:avLst>
-              <a:gd name="adj" fmla="val 4444"/>
+              <a:gd name="adj" fmla="val 4364"/>
             </a:avLst>
           </a:prstGeom>
           <a:solidFill>
@@ -2321,14 +2380,14 @@
       </p:sp>
       <p:sp>
         <p:nvSpPr>
-          <p:cNvPr id="7" name="Text 5"/>
+          <p:cNvPr id="9" name="Text 7"/>
           <p:cNvSpPr txBox="1"/>
           <p:nvPr/>
         </p:nvSpPr>
         <p:spPr>
           <a:xfrm>
-            <a:off x="3429000" y="1508760"/>
-            <a:ext cx="2286000" cy="1051560"/>
+            <a:off x="4892040" y="1298448"/>
+            <a:ext cx="3566160" cy="365760"/>
           </a:xfrm>
           <a:prstGeom prst="rect">
             <a:avLst/>
@@ -2338,198 +2397,500 @@
         </p:spPr>
         <p:txBody>
           <a:bodyPr wrap="square" lIns="0" tIns="0" rIns="0" bIns="0" rtlCol="0" anchor="ctr"/>
-          <a:lstStyle/>
-          <a:p>
-            <a:pPr algn="ctr" indent="0" marL="0">
-              <a:buNone/>
-            </a:pPr>
-            <a:r>
-              <a:rPr lang="en-US" sz="4800" b="1" dirty="0">
-                <a:solidFill>
-                  <a:srgbClr val="0B5D46"/>
-                </a:solidFill>
-              </a:rPr>
-              <a:t>Most</a:t>
-            </a:r>
-            <a:endParaRPr lang="en-US" sz="4800" dirty="0"/>
-          </a:p>
-        </p:txBody>
-      </p:sp>
-      <p:sp>
-        <p:nvSpPr>
-          <p:cNvPr id="8" name="Text 6"/>
-          <p:cNvSpPr txBox="1"/>
-          <p:nvPr/>
-        </p:nvSpPr>
-        <p:spPr>
-          <a:xfrm>
-            <a:off x="3429000" y="2697480"/>
-            <a:ext cx="2286000" cy="822960"/>
-          </a:xfrm>
-          <a:prstGeom prst="rect">
-            <a:avLst/>
-          </a:prstGeom>
-          <a:noFill/>
-          <a:ln/>
-        </p:spPr>
-        <p:txBody>
-          <a:bodyPr wrap="square" lIns="0" tIns="0" rIns="0" bIns="0" rtlCol="0" anchor="t"/>
-          <a:lstStyle/>
-          <a:p>
-            <a:pPr algn="ctr" indent="0" marL="0">
-              <a:buNone/>
-            </a:pPr>
-            <a:r>
-              <a:rPr lang="en-US" sz="1800" dirty="0">
-                <a:solidFill>
-                  <a:srgbClr val="464B53"/>
-                </a:solidFill>
-              </a:rPr>
-              <a:t>people with ALS lose their speech²</a:t>
-            </a:r>
-            <a:endParaRPr lang="en-US" sz="1800" dirty="0"/>
-          </a:p>
-        </p:txBody>
-      </p:sp>
-      <p:sp>
-        <p:nvSpPr>
-          <p:cNvPr id="9" name="card"/>
-          <p:cNvSpPr/>
-          <p:nvPr/>
-        </p:nvSpPr>
-        <p:spPr>
-          <a:xfrm>
-            <a:off x="6035040" y="1280160"/>
-            <a:ext cx="2651760" cy="2468880"/>
-          </a:xfrm>
-          <a:prstGeom prst="roundRect">
-            <a:avLst>
-              <a:gd name="adj" fmla="val 4444"/>
-            </a:avLst>
-          </a:prstGeom>
-          <a:solidFill>
-            <a:srgbClr val="FFFFFF"/>
-          </a:solidFill>
-          <a:ln w="9525">
-            <a:solidFill>
-              <a:srgbClr val="D9DCE0"/>
-            </a:solidFill>
-            <a:prstDash val="solid"/>
-          </a:ln>
-          <a:effectLst>
-            <a:outerShdw sx="100000" sy="100000" kx="0" ky="0" algn="bl" rotWithShape="0" blurRad="76200" dist="12700" dir="5400000">
-              <a:srgbClr val="000000">
-                <a:alpha val="8000"/>
-              </a:srgbClr>
-            </a:outerShdw>
-          </a:effectLst>
-        </p:spPr>
-      </p:sp>
-      <p:sp>
-        <p:nvSpPr>
-          <p:cNvPr id="10" name="Text 8"/>
-          <p:cNvSpPr txBox="1"/>
-          <p:nvPr/>
-        </p:nvSpPr>
-        <p:spPr>
-          <a:xfrm>
-            <a:off x="6217920" y="1508760"/>
-            <a:ext cx="2286000" cy="1051560"/>
-          </a:xfrm>
-          <a:prstGeom prst="rect">
-            <a:avLst/>
-          </a:prstGeom>
-          <a:noFill/>
-          <a:ln/>
-        </p:spPr>
-        <p:txBody>
-          <a:bodyPr wrap="square" lIns="0" tIns="0" rIns="0" bIns="0" rtlCol="0" anchor="ctr"/>
-          <a:lstStyle/>
-          <a:p>
-            <a:pPr algn="ctr" indent="0" marL="0">
-              <a:buNone/>
-            </a:pPr>
-            <a:r>
-              <a:rPr lang="en-US" sz="4800" b="1" dirty="0">
-                <a:solidFill>
-                  <a:srgbClr val="0B5D46"/>
-                </a:solidFill>
-              </a:rPr>
-              <a:t>$10,000+</a:t>
-            </a:r>
-            <a:endParaRPr lang="en-US" sz="4800" dirty="0"/>
-          </a:p>
-        </p:txBody>
-      </p:sp>
-      <p:sp>
-        <p:nvSpPr>
-          <p:cNvPr id="11" name="Text 9"/>
-          <p:cNvSpPr txBox="1"/>
-          <p:nvPr/>
-        </p:nvSpPr>
-        <p:spPr>
-          <a:xfrm>
-            <a:off x="6217920" y="2697480"/>
-            <a:ext cx="2286000" cy="822960"/>
-          </a:xfrm>
-          <a:prstGeom prst="rect">
-            <a:avLst/>
-          </a:prstGeom>
-          <a:noFill/>
-          <a:ln/>
-        </p:spPr>
-        <p:txBody>
-          <a:bodyPr wrap="square" lIns="0" tIns="0" rIns="0" bIns="0" rtlCol="0" anchor="t"/>
-          <a:lstStyle/>
-          <a:p>
-            <a:pPr algn="ctr" indent="0" marL="0">
-              <a:buNone/>
-            </a:pPr>
-            <a:r>
-              <a:rPr lang="en-US" sz="1800" dirty="0">
-                <a:solidFill>
-                  <a:srgbClr val="464B53"/>
-                </a:solidFill>
-              </a:rPr>
-              <a:t>eye-gaze devices³</a:t>
-            </a:r>
-            <a:endParaRPr lang="en-US" sz="1800" dirty="0"/>
-          </a:p>
-        </p:txBody>
-      </p:sp>
-      <p:sp>
-        <p:nvSpPr>
-          <p:cNvPr id="12" name="Text 10"/>
-          <p:cNvSpPr txBox="1"/>
-          <p:nvPr/>
-        </p:nvSpPr>
-        <p:spPr>
-          <a:xfrm>
-            <a:off x="457200" y="4206240"/>
-            <a:ext cx="7498080" cy="457200"/>
-          </a:xfrm>
-          <a:prstGeom prst="rect">
-            <a:avLst/>
-          </a:prstGeom>
-          <a:noFill/>
-          <a:ln/>
-        </p:spPr>
-        <p:txBody>
-          <a:bodyPr wrap="square" lIns="0" tIns="0" rIns="0" bIns="0" rtlCol="0" anchor="b"/>
           <a:lstStyle/>
           <a:p>
             <a:pPr indent="0" marL="0">
               <a:buNone/>
             </a:pPr>
             <a:r>
-              <a:rPr lang="en-US" sz="900" dirty="0">
+              <a:rPr lang="en-US" sz="2000" b="1" dirty="0">
+                <a:solidFill>
+                  <a:srgbClr val="0B5D46"/>
+                </a:solidFill>
+              </a:rPr>
+              <a:t>Also helps</a:t>
+            </a:r>
+            <a:endParaRPr lang="en-US" sz="2000" dirty="0"/>
+          </a:p>
+        </p:txBody>
+      </p:sp>
+      <p:pic>
+        <p:nvPicPr>
+          <p:cNvPr id="10" name="Image 0" descr="preencoded.png">    </p:cNvPr>
+          <p:cNvPicPr>
+            <a:picLocks noChangeAspect="1"/>
+          </p:cNvPicPr>
+          <p:nvPr/>
+        </p:nvPicPr>
+        <p:blipFill>
+          <a:blip r:embed="rId1"/>
+          <a:stretch>
+            <a:fillRect/>
+          </a:stretch>
+        </p:blipFill>
+        <p:spPr>
+          <a:xfrm>
+            <a:off x="4910328" y="1819656"/>
+            <a:ext cx="201168" cy="201168"/>
+          </a:xfrm>
+          <a:prstGeom prst="rect">
+            <a:avLst/>
+          </a:prstGeom>
+        </p:spPr>
+      </p:pic>
+      <p:sp>
+        <p:nvSpPr>
+          <p:cNvPr id="11" name="Text 8"/>
+          <p:cNvSpPr txBox="1"/>
+          <p:nvPr/>
+        </p:nvSpPr>
+        <p:spPr>
+          <a:xfrm>
+            <a:off x="5212080" y="1755648"/>
+            <a:ext cx="3337560" cy="329184"/>
+          </a:xfrm>
+          <a:prstGeom prst="rect">
+            <a:avLst/>
+          </a:prstGeom>
+          <a:noFill/>
+          <a:ln/>
+        </p:spPr>
+        <p:txBody>
+          <a:bodyPr wrap="square" lIns="0" tIns="0" rIns="0" bIns="0" rtlCol="0" anchor="ctr"/>
+          <a:lstStyle/>
+          <a:p>
+            <a:pPr indent="0" marL="0">
+              <a:buNone/>
+            </a:pPr>
+            <a:r>
+              <a:rPr lang="en-US" sz="1400" dirty="0">
+                <a:solidFill>
+                  <a:srgbClr val="121417"/>
+                </a:solidFill>
+              </a:rPr>
+              <a:t>Locked-in syndrome</a:t>
+            </a:r>
+            <a:endParaRPr lang="en-US" sz="1400" dirty="0"/>
+          </a:p>
+        </p:txBody>
+      </p:sp>
+      <p:pic>
+        <p:nvPicPr>
+          <p:cNvPr id="12" name="Image 1" descr="preencoded.png">    </p:cNvPr>
+          <p:cNvPicPr>
+            <a:picLocks noChangeAspect="1"/>
+          </p:cNvPicPr>
+          <p:nvPr/>
+        </p:nvPicPr>
+        <p:blipFill>
+          <a:blip r:embed="rId2"/>
+          <a:stretch>
+            <a:fillRect/>
+          </a:stretch>
+        </p:blipFill>
+        <p:spPr>
+          <a:xfrm>
+            <a:off x="4910328" y="2185416"/>
+            <a:ext cx="201168" cy="201168"/>
+          </a:xfrm>
+          <a:prstGeom prst="rect">
+            <a:avLst/>
+          </a:prstGeom>
+        </p:spPr>
+      </p:pic>
+      <p:sp>
+        <p:nvSpPr>
+          <p:cNvPr id="13" name="Text 9"/>
+          <p:cNvSpPr txBox="1"/>
+          <p:nvPr/>
+        </p:nvSpPr>
+        <p:spPr>
+          <a:xfrm>
+            <a:off x="5212080" y="2121408"/>
+            <a:ext cx="3337560" cy="329184"/>
+          </a:xfrm>
+          <a:prstGeom prst="rect">
+            <a:avLst/>
+          </a:prstGeom>
+          <a:noFill/>
+          <a:ln/>
+        </p:spPr>
+        <p:txBody>
+          <a:bodyPr wrap="square" lIns="0" tIns="0" rIns="0" bIns="0" rtlCol="0" anchor="ctr"/>
+          <a:lstStyle/>
+          <a:p>
+            <a:pPr indent="0" marL="0">
+              <a:buNone/>
+            </a:pPr>
+            <a:r>
+              <a:rPr lang="en-US" sz="1400" dirty="0">
+                <a:solidFill>
+                  <a:srgbClr val="121417"/>
+                </a:solidFill>
+              </a:rPr>
+              <a:t>Cerebral palsy</a:t>
+            </a:r>
+            <a:endParaRPr lang="en-US" sz="1400" dirty="0"/>
+          </a:p>
+        </p:txBody>
+      </p:sp>
+      <p:pic>
+        <p:nvPicPr>
+          <p:cNvPr id="14" name="Image 2" descr="preencoded.png">    </p:cNvPr>
+          <p:cNvPicPr>
+            <a:picLocks noChangeAspect="1"/>
+          </p:cNvPicPr>
+          <p:nvPr/>
+        </p:nvPicPr>
+        <p:blipFill>
+          <a:blip r:embed="rId3"/>
+          <a:stretch>
+            <a:fillRect/>
+          </a:stretch>
+        </p:blipFill>
+        <p:spPr>
+          <a:xfrm>
+            <a:off x="4910328" y="2551176"/>
+            <a:ext cx="201168" cy="201168"/>
+          </a:xfrm>
+          <a:prstGeom prst="rect">
+            <a:avLst/>
+          </a:prstGeom>
+        </p:spPr>
+      </p:pic>
+      <p:sp>
+        <p:nvSpPr>
+          <p:cNvPr id="15" name="Text 10"/>
+          <p:cNvSpPr txBox="1"/>
+          <p:nvPr/>
+        </p:nvSpPr>
+        <p:spPr>
+          <a:xfrm>
+            <a:off x="5212080" y="2487168"/>
+            <a:ext cx="3337560" cy="329184"/>
+          </a:xfrm>
+          <a:prstGeom prst="rect">
+            <a:avLst/>
+          </a:prstGeom>
+          <a:noFill/>
+          <a:ln/>
+        </p:spPr>
+        <p:txBody>
+          <a:bodyPr wrap="square" lIns="0" tIns="0" rIns="0" bIns="0" rtlCol="0" anchor="ctr"/>
+          <a:lstStyle/>
+          <a:p>
+            <a:pPr indent="0" marL="0">
+              <a:buNone/>
+            </a:pPr>
+            <a:r>
+              <a:rPr lang="en-US" sz="1400" dirty="0">
+                <a:solidFill>
+                  <a:srgbClr val="121417"/>
+                </a:solidFill>
+              </a:rPr>
+              <a:t>High spinal cord injury</a:t>
+            </a:r>
+            <a:endParaRPr lang="en-US" sz="1400" dirty="0"/>
+          </a:p>
+        </p:txBody>
+      </p:sp>
+      <p:pic>
+        <p:nvPicPr>
+          <p:cNvPr id="16" name="Image 3" descr="preencoded.png">    </p:cNvPr>
+          <p:cNvPicPr>
+            <a:picLocks noChangeAspect="1"/>
+          </p:cNvPicPr>
+          <p:nvPr/>
+        </p:nvPicPr>
+        <p:blipFill>
+          <a:blip r:embed="rId4"/>
+          <a:stretch>
+            <a:fillRect/>
+          </a:stretch>
+        </p:blipFill>
+        <p:spPr>
+          <a:xfrm>
+            <a:off x="4910328" y="2916936"/>
+            <a:ext cx="201168" cy="201168"/>
+          </a:xfrm>
+          <a:prstGeom prst="rect">
+            <a:avLst/>
+          </a:prstGeom>
+        </p:spPr>
+      </p:pic>
+      <p:sp>
+        <p:nvSpPr>
+          <p:cNvPr id="17" name="Text 11"/>
+          <p:cNvSpPr txBox="1"/>
+          <p:nvPr/>
+        </p:nvSpPr>
+        <p:spPr>
+          <a:xfrm>
+            <a:off x="5212080" y="2852928"/>
+            <a:ext cx="3337560" cy="329184"/>
+          </a:xfrm>
+          <a:prstGeom prst="rect">
+            <a:avLst/>
+          </a:prstGeom>
+          <a:noFill/>
+          <a:ln/>
+        </p:spPr>
+        <p:txBody>
+          <a:bodyPr wrap="square" lIns="0" tIns="0" rIns="0" bIns="0" rtlCol="0" anchor="ctr"/>
+          <a:lstStyle/>
+          <a:p>
+            <a:pPr indent="0" marL="0">
+              <a:buNone/>
+            </a:pPr>
+            <a:r>
+              <a:rPr lang="en-US" sz="1400" dirty="0">
+                <a:solidFill>
+                  <a:srgbClr val="121417"/>
+                </a:solidFill>
+              </a:rPr>
+              <a:t>Muscular dystrophy or MS</a:t>
+            </a:r>
+            <a:endParaRPr lang="en-US" sz="1400" dirty="0"/>
+          </a:p>
+        </p:txBody>
+      </p:sp>
+      <p:pic>
+        <p:nvPicPr>
+          <p:cNvPr id="18" name="Image 4" descr="preencoded.png">    </p:cNvPr>
+          <p:cNvPicPr>
+            <a:picLocks noChangeAspect="1"/>
+          </p:cNvPicPr>
+          <p:nvPr/>
+        </p:nvPicPr>
+        <p:blipFill>
+          <a:blip r:embed="rId5"/>
+          <a:stretch>
+            <a:fillRect/>
+          </a:stretch>
+        </p:blipFill>
+        <p:spPr>
+          <a:xfrm>
+            <a:off x="4910328" y="3282696"/>
+            <a:ext cx="201168" cy="201168"/>
+          </a:xfrm>
+          <a:prstGeom prst="rect">
+            <a:avLst/>
+          </a:prstGeom>
+        </p:spPr>
+      </p:pic>
+      <p:sp>
+        <p:nvSpPr>
+          <p:cNvPr id="19" name="Text 12"/>
+          <p:cNvSpPr txBox="1"/>
+          <p:nvPr/>
+        </p:nvSpPr>
+        <p:spPr>
+          <a:xfrm>
+            <a:off x="5212080" y="3218688"/>
+            <a:ext cx="3337560" cy="329184"/>
+          </a:xfrm>
+          <a:prstGeom prst="rect">
+            <a:avLst/>
+          </a:prstGeom>
+          <a:noFill/>
+          <a:ln/>
+        </p:spPr>
+        <p:txBody>
+          <a:bodyPr wrap="square" lIns="0" tIns="0" rIns="0" bIns="0" rtlCol="0" anchor="ctr"/>
+          <a:lstStyle/>
+          <a:p>
+            <a:pPr indent="0" marL="0">
+              <a:buNone/>
+            </a:pPr>
+            <a:r>
+              <a:rPr lang="en-US" sz="1400" dirty="0">
+                <a:solidFill>
+                  <a:srgbClr val="121417"/>
+                </a:solidFill>
+              </a:rPr>
+              <a:t>Intubated hospital patients</a:t>
+            </a:r>
+            <a:endParaRPr lang="en-US" sz="1400" dirty="0"/>
+          </a:p>
+        </p:txBody>
+      </p:sp>
+      <p:sp>
+        <p:nvSpPr>
+          <p:cNvPr id="20" name="Text 13"/>
+          <p:cNvSpPr txBox="1"/>
+          <p:nvPr/>
+        </p:nvSpPr>
+        <p:spPr>
+          <a:xfrm>
+            <a:off x="457200" y="3767328"/>
+            <a:ext cx="1325880" cy="411480"/>
+          </a:xfrm>
+          <a:prstGeom prst="rect">
+            <a:avLst/>
+          </a:prstGeom>
+          <a:noFill/>
+          <a:ln/>
+        </p:spPr>
+        <p:txBody>
+          <a:bodyPr wrap="square" lIns="0" tIns="0" rIns="0" bIns="0" rtlCol="0" anchor="ctr"/>
+          <a:lstStyle/>
+          <a:p>
+            <a:pPr indent="0" marL="0">
+              <a:buNone/>
+            </a:pPr>
+            <a:r>
+              <a:rPr lang="en-US" sz="2400" b="1" dirty="0">
+                <a:solidFill>
+                  <a:srgbClr val="0B5D46"/>
+                </a:solidFill>
+              </a:rPr>
+              <a:t>5M+</a:t>
+            </a:r>
+            <a:endParaRPr lang="en-US" sz="2400" dirty="0"/>
+          </a:p>
+        </p:txBody>
+      </p:sp>
+      <p:sp>
+        <p:nvSpPr>
+          <p:cNvPr id="21" name="Text 14"/>
+          <p:cNvSpPr txBox="1"/>
+          <p:nvPr/>
+        </p:nvSpPr>
+        <p:spPr>
+          <a:xfrm>
+            <a:off x="1828800" y="3767328"/>
+            <a:ext cx="2651760" cy="411480"/>
+          </a:xfrm>
+          <a:prstGeom prst="rect">
+            <a:avLst/>
+          </a:prstGeom>
+          <a:noFill/>
+          <a:ln/>
+        </p:spPr>
+        <p:txBody>
+          <a:bodyPr wrap="square" lIns="0" tIns="0" rIns="0" bIns="0" rtlCol="0" anchor="ctr"/>
+          <a:lstStyle/>
+          <a:p>
+            <a:pPr indent="0" marL="0">
+              <a:buNone/>
+            </a:pPr>
+            <a:r>
+              <a:rPr lang="en-US" sz="1400" dirty="0">
                 <a:solidFill>
                   <a:srgbClr val="464B53"/>
                 </a:solidFill>
               </a:rPr>
-              <a:t>¹ CommunicationFIRST, organization estimate (accessed 2026-10-24).  ² Eshghi et al., Scientific Reports 12:15713 (2022).  ³ Montana AT Program, Tobii I-16 eye-gaze device, est. $10,695 (older model).</a:t>
+              <a:t>Americans can't rely on speech³</a:t>
             </a:r>
-            <a:endParaRPr lang="en-US" sz="900" dirty="0"/>
+            <a:endParaRPr lang="en-US" sz="1400" dirty="0"/>
+          </a:p>
+        </p:txBody>
+      </p:sp>
+      <p:sp>
+        <p:nvSpPr>
+          <p:cNvPr id="22" name="Text 15"/>
+          <p:cNvSpPr txBox="1"/>
+          <p:nvPr/>
+        </p:nvSpPr>
+        <p:spPr>
+          <a:xfrm>
+            <a:off x="4663440" y="3767328"/>
+            <a:ext cx="1325880" cy="411480"/>
+          </a:xfrm>
+          <a:prstGeom prst="rect">
+            <a:avLst/>
+          </a:prstGeom>
+          <a:noFill/>
+          <a:ln/>
+        </p:spPr>
+        <p:txBody>
+          <a:bodyPr wrap="square" lIns="0" tIns="0" rIns="0" bIns="0" rtlCol="0" anchor="ctr"/>
+          <a:lstStyle/>
+          <a:p>
+            <a:pPr indent="0" marL="0">
+              <a:buNone/>
+            </a:pPr>
+            <a:r>
+              <a:rPr lang="en-US" sz="2400" b="1" dirty="0">
+                <a:solidFill>
+                  <a:srgbClr val="0B5D46"/>
+                </a:solidFill>
+              </a:rPr>
+              <a:t>$10,000+</a:t>
+            </a:r>
+            <a:endParaRPr lang="en-US" sz="2400" dirty="0"/>
+          </a:p>
+        </p:txBody>
+      </p:sp>
+      <p:sp>
+        <p:nvSpPr>
+          <p:cNvPr id="23" name="Text 16"/>
+          <p:cNvSpPr txBox="1"/>
+          <p:nvPr/>
+        </p:nvSpPr>
+        <p:spPr>
+          <a:xfrm>
+            <a:off x="6035040" y="3767328"/>
+            <a:ext cx="2651760" cy="411480"/>
+          </a:xfrm>
+          <a:prstGeom prst="rect">
+            <a:avLst/>
+          </a:prstGeom>
+          <a:noFill/>
+          <a:ln/>
+        </p:spPr>
+        <p:txBody>
+          <a:bodyPr wrap="square" lIns="0" tIns="0" rIns="0" bIns="0" rtlCol="0" anchor="ctr"/>
+          <a:lstStyle/>
+          <a:p>
+            <a:pPr indent="0" marL="0">
+              <a:buNone/>
+            </a:pPr>
+            <a:r>
+              <a:rPr lang="en-US" sz="1400" dirty="0">
+                <a:solidFill>
+                  <a:srgbClr val="464B53"/>
+                </a:solidFill>
+              </a:rPr>
+              <a:t>eye-gaze devices⁴</a:t>
+            </a:r>
+            <a:endParaRPr lang="en-US" sz="1400" dirty="0"/>
+          </a:p>
+        </p:txBody>
+      </p:sp>
+      <p:sp>
+        <p:nvSpPr>
+          <p:cNvPr id="24" name="Text 17"/>
+          <p:cNvSpPr txBox="1"/>
+          <p:nvPr/>
+        </p:nvSpPr>
+        <p:spPr>
+          <a:xfrm>
+            <a:off x="457200" y="4279392"/>
+            <a:ext cx="7406640" cy="411480"/>
+          </a:xfrm>
+          <a:prstGeom prst="rect">
+            <a:avLst/>
+          </a:prstGeom>
+          <a:noFill/>
+          <a:ln/>
+        </p:spPr>
+        <p:txBody>
+          <a:bodyPr wrap="square" lIns="0" tIns="0" rIns="0" bIns="0" rtlCol="0" anchor="t"/>
+          <a:lstStyle/>
+          <a:p>
+            <a:pPr indent="0" marL="0">
+              <a:buNone/>
+            </a:pPr>
+            <a:r>
+              <a:rPr lang="en-US" sz="800" dirty="0">
+                <a:solidFill>
+                  <a:srgbClr val="464B53"/>
+                </a:solidFill>
+              </a:rPr>
+              <a:t>¹ ALS Association, "What is ALS?" and "Changes in Thinking" (accessed 2026-10-24).  ² Eshghi et al., Scientific Reports 12:15713 (2022).  ³ CommunicationFIRST, organization estimate (accessed 2026-10-24).  ⁴ Montana AT Program, Tobii I-16 eye-gaze device, est. $10,695 (older model).</a:t>
+            </a:r>
+            <a:endParaRPr lang="en-US" sz="800" dirty="0"/>
           </a:p>
         </p:txBody>
       </p:sp>
@@ -3501,7 +3862,7 @@
                   <a:schemeClr val="tx1"/>
                 </a:solidFill>
               </a:rPr>
-              <a:t>One blink to answer</a:t>
+              <a:t>Your face is the controller</a:t>
             </a:r>
             <a:endParaRPr lang="en-US" sz="3200" dirty="0"/>
           </a:p>
@@ -3509,18 +3870,770 @@
       </p:sp>
       <p:sp>
         <p:nvSpPr>
-          <p:cNvPr id="3" name="device frame"/>
+          <p:cNvPr id="3" name="gesture row"/>
           <p:cNvSpPr/>
           <p:nvPr/>
         </p:nvSpPr>
         <p:spPr>
           <a:xfrm>
-            <a:off x="457200" y="1097280"/>
-            <a:ext cx="3977640" cy="3013095"/>
+            <a:off x="457200" y="1143000"/>
+            <a:ext cx="4572000" cy="603504"/>
           </a:xfrm>
           <a:prstGeom prst="roundRect">
             <a:avLst>
-              <a:gd name="adj" fmla="val 3035"/>
+              <a:gd name="adj" fmla="val 18182"/>
+            </a:avLst>
+          </a:prstGeom>
+          <a:solidFill>
+            <a:srgbClr val="FFFFFF"/>
+          </a:solidFill>
+          <a:ln w="9525">
+            <a:solidFill>
+              <a:srgbClr val="D9DCE0"/>
+            </a:solidFill>
+            <a:prstDash val="solid"/>
+          </a:ln>
+          <a:effectLst>
+            <a:outerShdw sx="100000" sy="100000" kx="0" ky="0" algn="bl" rotWithShape="0" blurRad="76200" dist="12700" dir="5400000">
+              <a:srgbClr val="000000">
+                <a:alpha val="8000"/>
+              </a:srgbClr>
+            </a:outerShdw>
+          </a:effectLst>
+        </p:spPr>
+      </p:sp>
+      <p:sp>
+        <p:nvSpPr>
+          <p:cNvPr id="4" name="icon LuChevronsUp"/>
+          <p:cNvSpPr/>
+          <p:nvPr/>
+        </p:nvSpPr>
+        <p:spPr>
+          <a:xfrm>
+            <a:off x="576072" y="1225296"/>
+            <a:ext cx="438912" cy="438912"/>
+          </a:xfrm>
+          <a:prstGeom prst="ellipse">
+            <a:avLst/>
+          </a:prstGeom>
+          <a:solidFill>
+            <a:srgbClr val="0B5D46"/>
+          </a:solidFill>
+          <a:ln w="12700">
+            <a:solidFill>
+              <a:srgbClr val="0B5D46"/>
+            </a:solidFill>
+            <a:prstDash val="solid"/>
+          </a:ln>
+        </p:spPr>
+      </p:sp>
+      <p:pic>
+        <p:nvPicPr>
+          <p:cNvPr id="5" name="Image 0" descr="preencoded.png">    </p:cNvPr>
+          <p:cNvPicPr>
+            <a:picLocks noChangeAspect="1"/>
+          </p:cNvPicPr>
+          <p:nvPr/>
+        </p:nvPicPr>
+        <p:blipFill>
+          <a:blip r:embed="rId1"/>
+          <a:stretch>
+            <a:fillRect/>
+          </a:stretch>
+        </p:blipFill>
+        <p:spPr>
+          <a:xfrm>
+            <a:off x="685800" y="1335024"/>
+            <a:ext cx="219456" cy="219456"/>
+          </a:xfrm>
+          <a:prstGeom prst="rect">
+            <a:avLst/>
+          </a:prstGeom>
+        </p:spPr>
+      </p:pic>
+      <p:sp>
+        <p:nvSpPr>
+          <p:cNvPr id="6" name="Text 3"/>
+          <p:cNvSpPr txBox="1"/>
+          <p:nvPr/>
+        </p:nvSpPr>
+        <p:spPr>
+          <a:xfrm>
+            <a:off x="1170432" y="1143000"/>
+            <a:ext cx="1554480" cy="603504"/>
+          </a:xfrm>
+          <a:prstGeom prst="rect">
+            <a:avLst/>
+          </a:prstGeom>
+          <a:noFill/>
+          <a:ln/>
+        </p:spPr>
+        <p:txBody>
+          <a:bodyPr wrap="square" lIns="0" tIns="0" rIns="0" bIns="0" rtlCol="0" anchor="ctr"/>
+          <a:lstStyle/>
+          <a:p>
+            <a:pPr indent="0" marL="0">
+              <a:buNone/>
+            </a:pPr>
+            <a:r>
+              <a:rPr lang="en-US" sz="1700" b="1" dirty="0">
+                <a:solidFill>
+                  <a:srgbClr val="121417"/>
+                </a:solidFill>
+              </a:rPr>
+              <a:t>Raise eyebrows</a:t>
+            </a:r>
+            <a:endParaRPr lang="en-US" sz="1700" dirty="0"/>
+          </a:p>
+        </p:txBody>
+      </p:sp>
+      <p:sp>
+        <p:nvSpPr>
+          <p:cNvPr id="7" name="Shape 4"/>
+          <p:cNvSpPr/>
+          <p:nvPr/>
+        </p:nvSpPr>
+        <p:spPr>
+          <a:xfrm>
+            <a:off x="2743200" y="1444752"/>
+            <a:ext cx="320040" cy="914"/>
+          </a:xfrm>
+          <a:prstGeom prst="line">
+            <a:avLst/>
+          </a:prstGeom>
+          <a:noFill/>
+          <a:ln w="19050">
+            <a:solidFill>
+              <a:srgbClr val="0B5D46"/>
+            </a:solidFill>
+            <a:prstDash val="solid"/>
+            <a:tailEnd type="triangle"/>
+          </a:ln>
+        </p:spPr>
+      </p:sp>
+      <p:sp>
+        <p:nvSpPr>
+          <p:cNvPr id="8" name="Text 5"/>
+          <p:cNvSpPr txBox="1"/>
+          <p:nvPr/>
+        </p:nvSpPr>
+        <p:spPr>
+          <a:xfrm>
+            <a:off x="3200400" y="1143000"/>
+            <a:ext cx="1783080" cy="603504"/>
+          </a:xfrm>
+          <a:prstGeom prst="rect">
+            <a:avLst/>
+          </a:prstGeom>
+          <a:noFill/>
+          <a:ln/>
+        </p:spPr>
+        <p:txBody>
+          <a:bodyPr wrap="square" lIns="0" tIns="0" rIns="0" bIns="0" rtlCol="0" anchor="ctr"/>
+          <a:lstStyle/>
+          <a:p>
+            <a:pPr indent="0" marL="0">
+              <a:buNone/>
+            </a:pPr>
+            <a:r>
+              <a:rPr lang="en-US" sz="1600" b="1" dirty="0">
+                <a:solidFill>
+                  <a:srgbClr val="0B5D46"/>
+                </a:solidFill>
+              </a:rPr>
+              <a:t>Next option</a:t>
+            </a:r>
+            <a:endParaRPr lang="en-US" sz="1600" dirty="0"/>
+          </a:p>
+        </p:txBody>
+      </p:sp>
+      <p:sp>
+        <p:nvSpPr>
+          <p:cNvPr id="9" name="gesture row"/>
+          <p:cNvSpPr/>
+          <p:nvPr/>
+        </p:nvSpPr>
+        <p:spPr>
+          <a:xfrm>
+            <a:off x="457200" y="1856232"/>
+            <a:ext cx="4572000" cy="603504"/>
+          </a:xfrm>
+          <a:prstGeom prst="roundRect">
+            <a:avLst>
+              <a:gd name="adj" fmla="val 18182"/>
+            </a:avLst>
+          </a:prstGeom>
+          <a:solidFill>
+            <a:srgbClr val="FFFFFF"/>
+          </a:solidFill>
+          <a:ln w="9525">
+            <a:solidFill>
+              <a:srgbClr val="D9DCE0"/>
+            </a:solidFill>
+            <a:prstDash val="solid"/>
+          </a:ln>
+          <a:effectLst>
+            <a:outerShdw sx="100000" sy="100000" kx="0" ky="0" algn="bl" rotWithShape="0" blurRad="76200" dist="12700" dir="5400000">
+              <a:srgbClr val="000000">
+                <a:alpha val="8000"/>
+              </a:srgbClr>
+            </a:outerShdw>
+          </a:effectLst>
+        </p:spPr>
+      </p:sp>
+      <p:sp>
+        <p:nvSpPr>
+          <p:cNvPr id="10" name="icon LuFastForward"/>
+          <p:cNvSpPr/>
+          <p:nvPr/>
+        </p:nvSpPr>
+        <p:spPr>
+          <a:xfrm>
+            <a:off x="576072" y="1938528"/>
+            <a:ext cx="438912" cy="438912"/>
+          </a:xfrm>
+          <a:prstGeom prst="ellipse">
+            <a:avLst/>
+          </a:prstGeom>
+          <a:solidFill>
+            <a:srgbClr val="0B5D46"/>
+          </a:solidFill>
+          <a:ln w="12700">
+            <a:solidFill>
+              <a:srgbClr val="0B5D46"/>
+            </a:solidFill>
+            <a:prstDash val="solid"/>
+          </a:ln>
+        </p:spPr>
+      </p:sp>
+      <p:pic>
+        <p:nvPicPr>
+          <p:cNvPr id="11" name="Image 1" descr="preencoded.png">    </p:cNvPr>
+          <p:cNvPicPr>
+            <a:picLocks noChangeAspect="1"/>
+          </p:cNvPicPr>
+          <p:nvPr/>
+        </p:nvPicPr>
+        <p:blipFill>
+          <a:blip r:embed="rId2"/>
+          <a:stretch>
+            <a:fillRect/>
+          </a:stretch>
+        </p:blipFill>
+        <p:spPr>
+          <a:xfrm>
+            <a:off x="685800" y="2048256"/>
+            <a:ext cx="219456" cy="219456"/>
+          </a:xfrm>
+          <a:prstGeom prst="rect">
+            <a:avLst/>
+          </a:prstGeom>
+        </p:spPr>
+      </p:pic>
+      <p:sp>
+        <p:nvSpPr>
+          <p:cNvPr id="12" name="Text 8"/>
+          <p:cNvSpPr txBox="1"/>
+          <p:nvPr/>
+        </p:nvSpPr>
+        <p:spPr>
+          <a:xfrm>
+            <a:off x="1170432" y="1856232"/>
+            <a:ext cx="1554480" cy="603504"/>
+          </a:xfrm>
+          <a:prstGeom prst="rect">
+            <a:avLst/>
+          </a:prstGeom>
+          <a:noFill/>
+          <a:ln/>
+        </p:spPr>
+        <p:txBody>
+          <a:bodyPr wrap="square" lIns="0" tIns="0" rIns="0" bIns="0" rtlCol="0" anchor="ctr"/>
+          <a:lstStyle/>
+          <a:p>
+            <a:pPr indent="0" marL="0">
+              <a:buNone/>
+            </a:pPr>
+            <a:r>
+              <a:rPr lang="en-US" sz="1700" b="1" dirty="0">
+                <a:solidFill>
+                  <a:srgbClr val="121417"/>
+                </a:solidFill>
+              </a:rPr>
+              <a:t>Keep them up</a:t>
+            </a:r>
+            <a:endParaRPr lang="en-US" sz="1700" dirty="0"/>
+          </a:p>
+        </p:txBody>
+      </p:sp>
+      <p:sp>
+        <p:nvSpPr>
+          <p:cNvPr id="13" name="Shape 9"/>
+          <p:cNvSpPr/>
+          <p:nvPr/>
+        </p:nvSpPr>
+        <p:spPr>
+          <a:xfrm>
+            <a:off x="2743200" y="2157984"/>
+            <a:ext cx="320040" cy="914"/>
+          </a:xfrm>
+          <a:prstGeom prst="line">
+            <a:avLst/>
+          </a:prstGeom>
+          <a:noFill/>
+          <a:ln w="19050">
+            <a:solidFill>
+              <a:srgbClr val="0B5D46"/>
+            </a:solidFill>
+            <a:prstDash val="solid"/>
+            <a:tailEnd type="triangle"/>
+          </a:ln>
+        </p:spPr>
+      </p:sp>
+      <p:sp>
+        <p:nvSpPr>
+          <p:cNvPr id="14" name="Text 10"/>
+          <p:cNvSpPr txBox="1"/>
+          <p:nvPr/>
+        </p:nvSpPr>
+        <p:spPr>
+          <a:xfrm>
+            <a:off x="3200400" y="1856232"/>
+            <a:ext cx="1783080" cy="603504"/>
+          </a:xfrm>
+          <a:prstGeom prst="rect">
+            <a:avLst/>
+          </a:prstGeom>
+          <a:noFill/>
+          <a:ln/>
+        </p:spPr>
+        <p:txBody>
+          <a:bodyPr wrap="square" lIns="0" tIns="0" rIns="0" bIns="0" rtlCol="0" anchor="ctr"/>
+          <a:lstStyle/>
+          <a:p>
+            <a:pPr indent="0" marL="0">
+              <a:buNone/>
+            </a:pPr>
+            <a:r>
+              <a:rPr lang="en-US" sz="1600" b="1" dirty="0">
+                <a:solidFill>
+                  <a:srgbClr val="0B5D46"/>
+                </a:solidFill>
+              </a:rPr>
+              <a:t>Keep moving</a:t>
+            </a:r>
+            <a:endParaRPr lang="en-US" sz="1600" dirty="0"/>
+          </a:p>
+        </p:txBody>
+      </p:sp>
+      <p:sp>
+        <p:nvSpPr>
+          <p:cNvPr id="15" name="gesture row"/>
+          <p:cNvSpPr/>
+          <p:nvPr/>
+        </p:nvSpPr>
+        <p:spPr>
+          <a:xfrm>
+            <a:off x="457200" y="2569464"/>
+            <a:ext cx="4572000" cy="603504"/>
+          </a:xfrm>
+          <a:prstGeom prst="roundRect">
+            <a:avLst>
+              <a:gd name="adj" fmla="val 18182"/>
+            </a:avLst>
+          </a:prstGeom>
+          <a:solidFill>
+            <a:srgbClr val="FFFFFF"/>
+          </a:solidFill>
+          <a:ln w="9525">
+            <a:solidFill>
+              <a:srgbClr val="D9DCE0"/>
+            </a:solidFill>
+            <a:prstDash val="solid"/>
+          </a:ln>
+          <a:effectLst>
+            <a:outerShdw sx="100000" sy="100000" kx="0" ky="0" algn="bl" rotWithShape="0" blurRad="76200" dist="12700" dir="5400000">
+              <a:srgbClr val="000000">
+                <a:alpha val="8000"/>
+              </a:srgbClr>
+            </a:outerShdw>
+          </a:effectLst>
+        </p:spPr>
+      </p:sp>
+      <p:sp>
+        <p:nvSpPr>
+          <p:cNvPr id="16" name="icon LuUndo2"/>
+          <p:cNvSpPr/>
+          <p:nvPr/>
+        </p:nvSpPr>
+        <p:spPr>
+          <a:xfrm>
+            <a:off x="576072" y="2651760"/>
+            <a:ext cx="438912" cy="438912"/>
+          </a:xfrm>
+          <a:prstGeom prst="ellipse">
+            <a:avLst/>
+          </a:prstGeom>
+          <a:solidFill>
+            <a:srgbClr val="0B5D46"/>
+          </a:solidFill>
+          <a:ln w="12700">
+            <a:solidFill>
+              <a:srgbClr val="0B5D46"/>
+            </a:solidFill>
+            <a:prstDash val="solid"/>
+          </a:ln>
+        </p:spPr>
+      </p:sp>
+      <p:pic>
+        <p:nvPicPr>
+          <p:cNvPr id="17" name="Image 2" descr="preencoded.png">    </p:cNvPr>
+          <p:cNvPicPr>
+            <a:picLocks noChangeAspect="1"/>
+          </p:cNvPicPr>
+          <p:nvPr/>
+        </p:nvPicPr>
+        <p:blipFill>
+          <a:blip r:embed="rId3"/>
+          <a:stretch>
+            <a:fillRect/>
+          </a:stretch>
+        </p:blipFill>
+        <p:spPr>
+          <a:xfrm>
+            <a:off x="685800" y="2761488"/>
+            <a:ext cx="219456" cy="219456"/>
+          </a:xfrm>
+          <a:prstGeom prst="rect">
+            <a:avLst/>
+          </a:prstGeom>
+        </p:spPr>
+      </p:pic>
+      <p:sp>
+        <p:nvSpPr>
+          <p:cNvPr id="18" name="Text 13"/>
+          <p:cNvSpPr txBox="1"/>
+          <p:nvPr/>
+        </p:nvSpPr>
+        <p:spPr>
+          <a:xfrm>
+            <a:off x="1170432" y="2569464"/>
+            <a:ext cx="1554480" cy="603504"/>
+          </a:xfrm>
+          <a:prstGeom prst="rect">
+            <a:avLst/>
+          </a:prstGeom>
+          <a:noFill/>
+          <a:ln/>
+        </p:spPr>
+        <p:txBody>
+          <a:bodyPr wrap="square" lIns="0" tIns="0" rIns="0" bIns="0" rtlCol="0" anchor="ctr"/>
+          <a:lstStyle/>
+          <a:p>
+            <a:pPr indent="0" marL="0">
+              <a:buNone/>
+            </a:pPr>
+            <a:r>
+              <a:rPr lang="en-US" sz="1700" b="1" dirty="0">
+                <a:solidFill>
+                  <a:srgbClr val="121417"/>
+                </a:solidFill>
+              </a:rPr>
+              <a:t>Drop your jaw</a:t>
+            </a:r>
+            <a:endParaRPr lang="en-US" sz="1700" dirty="0"/>
+          </a:p>
+        </p:txBody>
+      </p:sp>
+      <p:sp>
+        <p:nvSpPr>
+          <p:cNvPr id="19" name="Shape 14"/>
+          <p:cNvSpPr/>
+          <p:nvPr/>
+        </p:nvSpPr>
+        <p:spPr>
+          <a:xfrm>
+            <a:off x="2743200" y="2871216"/>
+            <a:ext cx="320040" cy="914"/>
+          </a:xfrm>
+          <a:prstGeom prst="line">
+            <a:avLst/>
+          </a:prstGeom>
+          <a:noFill/>
+          <a:ln w="19050">
+            <a:solidFill>
+              <a:srgbClr val="0B5D46"/>
+            </a:solidFill>
+            <a:prstDash val="solid"/>
+            <a:tailEnd type="triangle"/>
+          </a:ln>
+        </p:spPr>
+      </p:sp>
+      <p:sp>
+        <p:nvSpPr>
+          <p:cNvPr id="20" name="Text 15"/>
+          <p:cNvSpPr txBox="1"/>
+          <p:nvPr/>
+        </p:nvSpPr>
+        <p:spPr>
+          <a:xfrm>
+            <a:off x="3200400" y="2569464"/>
+            <a:ext cx="1783080" cy="603504"/>
+          </a:xfrm>
+          <a:prstGeom prst="rect">
+            <a:avLst/>
+          </a:prstGeom>
+          <a:noFill/>
+          <a:ln/>
+        </p:spPr>
+        <p:txBody>
+          <a:bodyPr wrap="square" lIns="0" tIns="0" rIns="0" bIns="0" rtlCol="0" anchor="ctr"/>
+          <a:lstStyle/>
+          <a:p>
+            <a:pPr indent="0" marL="0">
+              <a:buNone/>
+            </a:pPr>
+            <a:r>
+              <a:rPr lang="en-US" sz="1600" b="1" dirty="0">
+                <a:solidFill>
+                  <a:srgbClr val="0B5D46"/>
+                </a:solidFill>
+              </a:rPr>
+              <a:t>Go back</a:t>
+            </a:r>
+            <a:endParaRPr lang="en-US" sz="1600" dirty="0"/>
+          </a:p>
+        </p:txBody>
+      </p:sp>
+      <p:sp>
+        <p:nvSpPr>
+          <p:cNvPr id="21" name="gesture row"/>
+          <p:cNvSpPr/>
+          <p:nvPr/>
+        </p:nvSpPr>
+        <p:spPr>
+          <a:xfrm>
+            <a:off x="457200" y="3282696"/>
+            <a:ext cx="4572000" cy="603504"/>
+          </a:xfrm>
+          <a:prstGeom prst="roundRect">
+            <a:avLst>
+              <a:gd name="adj" fmla="val 18182"/>
+            </a:avLst>
+          </a:prstGeom>
+          <a:solidFill>
+            <a:srgbClr val="FFFFFF"/>
+          </a:solidFill>
+          <a:ln w="9525">
+            <a:solidFill>
+              <a:srgbClr val="D9DCE0"/>
+            </a:solidFill>
+            <a:prstDash val="solid"/>
+          </a:ln>
+          <a:effectLst>
+            <a:outerShdw sx="100000" sy="100000" kx="0" ky="0" algn="bl" rotWithShape="0" blurRad="76200" dist="12700" dir="5400000">
+              <a:srgbClr val="000000">
+                <a:alpha val="8000"/>
+              </a:srgbClr>
+            </a:outerShdw>
+          </a:effectLst>
+        </p:spPr>
+      </p:sp>
+      <p:sp>
+        <p:nvSpPr>
+          <p:cNvPr id="22" name="icon LuEyeClosed"/>
+          <p:cNvSpPr/>
+          <p:nvPr/>
+        </p:nvSpPr>
+        <p:spPr>
+          <a:xfrm>
+            <a:off x="576072" y="3364992"/>
+            <a:ext cx="438912" cy="438912"/>
+          </a:xfrm>
+          <a:prstGeom prst="ellipse">
+            <a:avLst/>
+          </a:prstGeom>
+          <a:solidFill>
+            <a:srgbClr val="0B5D46"/>
+          </a:solidFill>
+          <a:ln w="12700">
+            <a:solidFill>
+              <a:srgbClr val="0B5D46"/>
+            </a:solidFill>
+            <a:prstDash val="solid"/>
+          </a:ln>
+        </p:spPr>
+      </p:sp>
+      <p:pic>
+        <p:nvPicPr>
+          <p:cNvPr id="23" name="Image 3" descr="preencoded.png">    </p:cNvPr>
+          <p:cNvPicPr>
+            <a:picLocks noChangeAspect="1"/>
+          </p:cNvPicPr>
+          <p:nvPr/>
+        </p:nvPicPr>
+        <p:blipFill>
+          <a:blip r:embed="rId4"/>
+          <a:stretch>
+            <a:fillRect/>
+          </a:stretch>
+        </p:blipFill>
+        <p:spPr>
+          <a:xfrm>
+            <a:off x="685800" y="3474720"/>
+            <a:ext cx="219456" cy="219456"/>
+          </a:xfrm>
+          <a:prstGeom prst="rect">
+            <a:avLst/>
+          </a:prstGeom>
+        </p:spPr>
+      </p:pic>
+      <p:sp>
+        <p:nvSpPr>
+          <p:cNvPr id="24" name="Text 18"/>
+          <p:cNvSpPr txBox="1"/>
+          <p:nvPr/>
+        </p:nvSpPr>
+        <p:spPr>
+          <a:xfrm>
+            <a:off x="1170432" y="3282696"/>
+            <a:ext cx="1554480" cy="603504"/>
+          </a:xfrm>
+          <a:prstGeom prst="rect">
+            <a:avLst/>
+          </a:prstGeom>
+          <a:noFill/>
+          <a:ln/>
+        </p:spPr>
+        <p:txBody>
+          <a:bodyPr wrap="square" lIns="0" tIns="0" rIns="0" bIns="0" rtlCol="0" anchor="ctr"/>
+          <a:lstStyle/>
+          <a:p>
+            <a:pPr indent="0" marL="0">
+              <a:buNone/>
+            </a:pPr>
+            <a:r>
+              <a:rPr lang="en-US" sz="1700" b="1" dirty="0">
+                <a:solidFill>
+                  <a:srgbClr val="121417"/>
+                </a:solidFill>
+              </a:rPr>
+              <a:t>Long blink</a:t>
+            </a:r>
+            <a:endParaRPr lang="en-US" sz="1700" dirty="0"/>
+          </a:p>
+        </p:txBody>
+      </p:sp>
+      <p:sp>
+        <p:nvSpPr>
+          <p:cNvPr id="25" name="Shape 19"/>
+          <p:cNvSpPr/>
+          <p:nvPr/>
+        </p:nvSpPr>
+        <p:spPr>
+          <a:xfrm>
+            <a:off x="2743200" y="3584448"/>
+            <a:ext cx="320040" cy="914"/>
+          </a:xfrm>
+          <a:prstGeom prst="line">
+            <a:avLst/>
+          </a:prstGeom>
+          <a:noFill/>
+          <a:ln w="19050">
+            <a:solidFill>
+              <a:srgbClr val="0B5D46"/>
+            </a:solidFill>
+            <a:prstDash val="solid"/>
+            <a:tailEnd type="triangle"/>
+          </a:ln>
+        </p:spPr>
+      </p:sp>
+      <p:sp>
+        <p:nvSpPr>
+          <p:cNvPr id="26" name="Text 20"/>
+          <p:cNvSpPr txBox="1"/>
+          <p:nvPr/>
+        </p:nvSpPr>
+        <p:spPr>
+          <a:xfrm>
+            <a:off x="3200400" y="3282696"/>
+            <a:ext cx="1783080" cy="603504"/>
+          </a:xfrm>
+          <a:prstGeom prst="rect">
+            <a:avLst/>
+          </a:prstGeom>
+          <a:noFill/>
+          <a:ln/>
+        </p:spPr>
+        <p:txBody>
+          <a:bodyPr wrap="square" lIns="0" tIns="0" rIns="0" bIns="0" rtlCol="0" anchor="ctr"/>
+          <a:lstStyle/>
+          <a:p>
+            <a:pPr indent="0" marL="0">
+              <a:buNone/>
+            </a:pPr>
+            <a:r>
+              <a:rPr lang="en-US" sz="1600" b="1" dirty="0">
+                <a:solidFill>
+                  <a:srgbClr val="0B5D46"/>
+                </a:solidFill>
+              </a:rPr>
+              <a:t>Choose and speak</a:t>
+            </a:r>
+            <a:endParaRPr lang="en-US" sz="1600" dirty="0"/>
+          </a:p>
+        </p:txBody>
+      </p:sp>
+      <p:sp>
+        <p:nvSpPr>
+          <p:cNvPr id="27" name="Text 21"/>
+          <p:cNvSpPr txBox="1"/>
+          <p:nvPr/>
+        </p:nvSpPr>
+        <p:spPr>
+          <a:xfrm>
+            <a:off x="457200" y="4069080"/>
+            <a:ext cx="7498080" cy="411480"/>
+          </a:xfrm>
+          <a:prstGeom prst="rect">
+            <a:avLst/>
+          </a:prstGeom>
+          <a:noFill/>
+          <a:ln/>
+        </p:spPr>
+        <p:txBody>
+          <a:bodyPr wrap="square" lIns="0" tIns="0" rIns="0" bIns="0" rtlCol="0" anchor="ctr"/>
+          <a:lstStyle/>
+          <a:p>
+            <a:pPr indent="0" marL="0">
+              <a:buNone/>
+            </a:pPr>
+            <a:r>
+              <a:rPr lang="en-US" sz="1800" b="1" dirty="0">
+                <a:solidFill>
+                  <a:srgbClr val="464B53"/>
+                </a:solidFill>
+              </a:rPr>
+              <a:t>One-minute calibration learns your face. Partner just talks.</a:t>
+            </a:r>
+            <a:endParaRPr lang="en-US" sz="1800" dirty="0"/>
+          </a:p>
+        </p:txBody>
+      </p:sp>
+      <p:sp>
+        <p:nvSpPr>
+          <p:cNvPr id="28" name="device frame"/>
+          <p:cNvSpPr/>
+          <p:nvPr/>
+        </p:nvSpPr>
+        <p:spPr>
+          <a:xfrm>
+            <a:off x="5349240" y="1143000"/>
+            <a:ext cx="3337560" cy="2533391"/>
+          </a:xfrm>
+          <a:prstGeom prst="roundRect">
+            <a:avLst>
+              <a:gd name="adj" fmla="val 3609"/>
             </a:avLst>
           </a:prstGeom>
           <a:solidFill>
@@ -3543,194 +4656,28 @@
       </p:sp>
       <p:pic>
         <p:nvPicPr>
-          <p:cNvPr id="4" name="Image 0" descr="Board: partner asked Are you coming to dinner tonight, two live replies">    </p:cNvPr>
+          <p:cNvPr id="29" name="Image 4" descr="Board with the highlighted reply card">    </p:cNvPr>
           <p:cNvPicPr>
             <a:picLocks noChangeAspect="1"/>
           </p:cNvPicPr>
           <p:nvPr/>
         </p:nvPicPr>
         <p:blipFill>
-          <a:blip r:embed="rId1"/>
+          <a:blip r:embed="rId5"/>
           <a:stretch>
             <a:fillRect/>
           </a:stretch>
         </p:blipFill>
         <p:spPr>
           <a:xfrm>
-            <a:off x="521208" y="1161288"/>
-            <a:ext cx="3849624" cy="2885079"/>
+            <a:off x="5413248" y="1207008"/>
+            <a:ext cx="3209544" cy="2405375"/>
           </a:xfrm>
           <a:prstGeom prst="rect">
             <a:avLst/>
           </a:prstGeom>
         </p:spPr>
       </p:pic>
-      <p:sp>
-        <p:nvSpPr>
-          <p:cNvPr id="5" name="device frame"/>
-          <p:cNvSpPr/>
-          <p:nvPr/>
-        </p:nvSpPr>
-        <p:spPr>
-          <a:xfrm>
-            <a:off x="4709160" y="1097280"/>
-            <a:ext cx="3977640" cy="3013095"/>
-          </a:xfrm>
-          <a:prstGeom prst="roundRect">
-            <a:avLst>
-              <a:gd name="adj" fmla="val 3035"/>
-            </a:avLst>
-          </a:prstGeom>
-          <a:solidFill>
-            <a:srgbClr val="1B1E22"/>
-          </a:solidFill>
-          <a:ln w="9525">
-            <a:solidFill>
-              <a:srgbClr val="1B1E22"/>
-            </a:solidFill>
-            <a:prstDash val="solid"/>
-          </a:ln>
-          <a:effectLst>
-            <a:outerShdw sx="100000" sy="100000" kx="0" ky="0" algn="bl" rotWithShape="0" blurRad="101600" dist="25400" dir="5400000">
-              <a:srgbClr val="000000">
-                <a:alpha val="16000"/>
-              </a:srgbClr>
-            </a:outerShdw>
-          </a:effectLst>
-        </p:spPr>
-      </p:sp>
-      <p:pic>
-        <p:nvPicPr>
-          <p:cNvPr id="6" name="Image 1" descr="Other ways to answer: What time, Who's coming, Decide later, Where at">    </p:cNvPr>
-          <p:cNvPicPr>
-            <a:picLocks noChangeAspect="1"/>
-          </p:cNvPicPr>
-          <p:nvPr/>
-        </p:nvPicPr>
-        <p:blipFill>
-          <a:blip r:embed="rId2"/>
-          <a:stretch>
-            <a:fillRect/>
-          </a:stretch>
-        </p:blipFill>
-        <p:spPr>
-          <a:xfrm>
-            <a:off x="4773168" y="1161288"/>
-            <a:ext cx="3849624" cy="2885079"/>
-          </a:xfrm>
-          <a:prstGeom prst="rect">
-            <a:avLst/>
-          </a:prstGeom>
-        </p:spPr>
-      </p:pic>
-      <p:sp>
-        <p:nvSpPr>
-          <p:cNvPr id="7" name="Text 3"/>
-          <p:cNvSpPr txBox="1"/>
-          <p:nvPr/>
-        </p:nvSpPr>
-        <p:spPr>
-          <a:xfrm>
-            <a:off x="457200" y="4247535"/>
-            <a:ext cx="3977640" cy="365760"/>
-          </a:xfrm>
-          <a:prstGeom prst="rect">
-            <a:avLst/>
-          </a:prstGeom>
-          <a:noFill/>
-          <a:ln/>
-        </p:spPr>
-        <p:txBody>
-          <a:bodyPr wrap="square" lIns="0" tIns="0" rIns="0" bIns="0" rtlCol="0" anchor="ctr"/>
-          <a:lstStyle/>
-          <a:p>
-            <a:pPr algn="ctr" indent="0" marL="0">
-              <a:buNone/>
-            </a:pPr>
-            <a:r>
-              <a:rPr lang="en-US" sz="1800" b="1" dirty="0">
-                <a:solidFill>
-                  <a:srgbClr val="121417"/>
-                </a:solidFill>
-              </a:rPr>
-              <a:t>Two best replies</a:t>
-            </a:r>
-            <a:endParaRPr lang="en-US" sz="1800" dirty="0"/>
-          </a:p>
-        </p:txBody>
-      </p:sp>
-      <p:sp>
-        <p:nvSpPr>
-          <p:cNvPr id="8" name="Text 4"/>
-          <p:cNvSpPr txBox="1"/>
-          <p:nvPr/>
-        </p:nvSpPr>
-        <p:spPr>
-          <a:xfrm>
-            <a:off x="4709160" y="4247535"/>
-            <a:ext cx="3977640" cy="365760"/>
-          </a:xfrm>
-          <a:prstGeom prst="rect">
-            <a:avLst/>
-          </a:prstGeom>
-          <a:noFill/>
-          <a:ln/>
-        </p:spPr>
-        <p:txBody>
-          <a:bodyPr wrap="square" lIns="0" tIns="0" rIns="0" bIns="0" rtlCol="0" anchor="ctr"/>
-          <a:lstStyle/>
-          <a:p>
-            <a:pPr algn="ctr" indent="0" marL="0">
-              <a:buNone/>
-            </a:pPr>
-            <a:r>
-              <a:rPr lang="en-US" sz="1800" b="1" dirty="0">
-                <a:solidFill>
-                  <a:srgbClr val="0B5D46"/>
-                </a:solidFill>
-              </a:rPr>
-              <a:t>Or pick a direction</a:t>
-            </a:r>
-            <a:endParaRPr lang="en-US" sz="1800" dirty="0"/>
-          </a:p>
-        </p:txBody>
-      </p:sp>
-      <p:sp>
-        <p:nvSpPr>
-          <p:cNvPr id="9" name="Text 5"/>
-          <p:cNvSpPr txBox="1"/>
-          <p:nvPr/>
-        </p:nvSpPr>
-        <p:spPr>
-          <a:xfrm>
-            <a:off x="457200" y="4754880"/>
-            <a:ext cx="7406640" cy="256032"/>
-          </a:xfrm>
-          <a:prstGeom prst="rect">
-            <a:avLst/>
-          </a:prstGeom>
-          <a:noFill/>
-          <a:ln/>
-        </p:spPr>
-        <p:txBody>
-          <a:bodyPr wrap="square" lIns="0" tIns="0" rIns="0" bIns="0" rtlCol="0" anchor="ctr"/>
-          <a:lstStyle/>
-          <a:p>
-            <a:pPr indent="0" marL="0">
-              <a:buNone/>
-            </a:pPr>
-            <a:r>
-              <a:rPr lang="en-US" sz="1000" dirty="0">
-                <a:solidFill>
-                  <a:srgbClr val="464B53"/>
-                </a:solidFill>
-              </a:rPr>
-              <a:t>Current build, iPad-size browser view, Live AI replies (wording varies run to run).</a:t>
-            </a:r>
-            <a:endParaRPr lang="en-US" sz="1000" dirty="0"/>
-          </a:p>
-        </p:txBody>
-      </p:sp>
       <p:sp>
         <p:nvSpPr>
           <p:cNvPr id="25" name="Slide Number Placeholder 0"/>
@@ -3836,15 +4783,49 @@
                   <a:schemeClr val="tx1"/>
                 </a:solidFill>
               </a:rPr>
-              <a:t>Simple, private, personal</a:t>
+              <a:t>One blink to answer</a:t>
             </a:r>
             <a:endParaRPr lang="en-US" sz="3200" dirty="0"/>
           </a:p>
         </p:txBody>
       </p:sp>
+      <p:sp>
+        <p:nvSpPr>
+          <p:cNvPr id="3" name="device frame"/>
+          <p:cNvSpPr/>
+          <p:nvPr/>
+        </p:nvSpPr>
+        <p:spPr>
+          <a:xfrm>
+            <a:off x="457200" y="1097280"/>
+            <a:ext cx="3977640" cy="3013095"/>
+          </a:xfrm>
+          <a:prstGeom prst="roundRect">
+            <a:avLst>
+              <a:gd name="adj" fmla="val 3035"/>
+            </a:avLst>
+          </a:prstGeom>
+          <a:solidFill>
+            <a:srgbClr val="1B1E22"/>
+          </a:solidFill>
+          <a:ln w="9525">
+            <a:solidFill>
+              <a:srgbClr val="1B1E22"/>
+            </a:solidFill>
+            <a:prstDash val="solid"/>
+          </a:ln>
+          <a:effectLst>
+            <a:outerShdw sx="100000" sy="100000" kx="0" ky="0" algn="bl" rotWithShape="0" blurRad="101600" dist="25400" dir="5400000">
+              <a:srgbClr val="000000">
+                <a:alpha val="16000"/>
+              </a:srgbClr>
+            </a:outerShdw>
+          </a:effectLst>
+        </p:spPr>
+      </p:sp>
       <p:pic>
         <p:nvPicPr>
-          <p:cNvPr id="3" name="Image 0" descr="Simplified architecture: iPad (camera, microphone, speaker), our Railway server, OpenAI and ElevenLabs">    </p:cNvPr>
+          <p:cNvPr id="4" name="Image 0" descr="Board: partner asked Are you coming to dinner tonight, two live replies">    </p:cNvPr>
           <p:cNvPicPr>
             <a:picLocks noChangeAspect="1"/>
           </p:cNvPicPr>
@@ -3858,8 +4839,8 @@
         </p:blipFill>
         <p:spPr>
           <a:xfrm>
-            <a:off x="365760" y="1417320"/>
-            <a:ext cx="5303520" cy="2430780"/>
+            <a:off x="521208" y="1161288"/>
+            <a:ext cx="3849624" cy="2885079"/>
           </a:xfrm>
           <a:prstGeom prst="rect">
             <a:avLst/>
@@ -3868,32 +4849,41 @@
       </p:pic>
       <p:sp>
         <p:nvSpPr>
-          <p:cNvPr id="4" name="icon LuScanFace"/>
+          <p:cNvPr id="5" name="device frame"/>
           <p:cNvSpPr/>
           <p:nvPr/>
         </p:nvSpPr>
         <p:spPr>
           <a:xfrm>
-            <a:off x="5989320" y="1508760"/>
-            <a:ext cx="548640" cy="548640"/>
-          </a:xfrm>
-          <a:prstGeom prst="ellipse">
-            <a:avLst/>
+            <a:off x="4709160" y="1097280"/>
+            <a:ext cx="3977640" cy="3013095"/>
+          </a:xfrm>
+          <a:prstGeom prst="roundRect">
+            <a:avLst>
+              <a:gd name="adj" fmla="val 3035"/>
+            </a:avLst>
           </a:prstGeom>
           <a:solidFill>
-            <a:srgbClr val="0B5D46"/>
+            <a:srgbClr val="1B1E22"/>
           </a:solidFill>
-          <a:ln w="12700">
+          <a:ln w="9525">
             <a:solidFill>
-              <a:srgbClr val="0B5D46"/>
+              <a:srgbClr val="1B1E22"/>
             </a:solidFill>
             <a:prstDash val="solid"/>
           </a:ln>
+          <a:effectLst>
+            <a:outerShdw sx="100000" sy="100000" kx="0" ky="0" algn="bl" rotWithShape="0" blurRad="101600" dist="25400" dir="5400000">
+              <a:srgbClr val="000000">
+                <a:alpha val="16000"/>
+              </a:srgbClr>
+            </a:outerShdw>
+          </a:effectLst>
         </p:spPr>
       </p:sp>
       <p:pic>
         <p:nvPicPr>
-          <p:cNvPr id="5" name="Image 1" descr="preencoded.png">    </p:cNvPr>
+          <p:cNvPr id="6" name="Image 1" descr="Other ways to answer: What time, Who's coming, Decide later, Where at">    </p:cNvPr>
           <p:cNvPicPr>
             <a:picLocks noChangeAspect="1"/>
           </p:cNvPicPr>
@@ -3907,8 +4897,8 @@
         </p:blipFill>
         <p:spPr>
           <a:xfrm>
-            <a:off x="6126480" y="1645920"/>
-            <a:ext cx="274320" cy="274320"/>
+            <a:off x="4773168" y="1161288"/>
+            <a:ext cx="3849624" cy="2885079"/>
           </a:xfrm>
           <a:prstGeom prst="rect">
             <a:avLst/>
@@ -3917,14 +4907,14 @@
       </p:pic>
       <p:sp>
         <p:nvSpPr>
-          <p:cNvPr id="6" name="Text 2"/>
+          <p:cNvPr id="7" name="Text 3"/>
           <p:cNvSpPr txBox="1"/>
           <p:nvPr/>
         </p:nvSpPr>
         <p:spPr>
           <a:xfrm>
-            <a:off x="6675120" y="1508760"/>
-            <a:ext cx="2057400" cy="548640"/>
+            <a:off x="457200" y="4247535"/>
+            <a:ext cx="3977640" cy="365760"/>
           </a:xfrm>
           <a:prstGeom prst="rect">
             <a:avLst/>
@@ -3936,80 +4926,31 @@
           <a:bodyPr wrap="square" lIns="0" tIns="0" rIns="0" bIns="0" rtlCol="0" anchor="ctr"/>
           <a:lstStyle/>
           <a:p>
-            <a:pPr indent="0" marL="0">
+            <a:pPr algn="ctr" indent="0" marL="0">
               <a:buNone/>
             </a:pPr>
             <a:r>
-              <a:rPr lang="en-US" sz="1600" b="1" dirty="0">
+              <a:rPr lang="en-US" sz="1800" b="1" dirty="0">
                 <a:solidFill>
                   <a:srgbClr val="121417"/>
                 </a:solidFill>
               </a:rPr>
-              <a:t>Calibrated to your face</a:t>
+              <a:t>Two best replies</a:t>
             </a:r>
-            <a:endParaRPr lang="en-US" sz="1600" dirty="0"/>
-          </a:p>
-        </p:txBody>
-      </p:sp>
-      <p:sp>
-        <p:nvSpPr>
-          <p:cNvPr id="7" name="icon LuLock"/>
-          <p:cNvSpPr/>
-          <p:nvPr/>
-        </p:nvSpPr>
-        <p:spPr>
-          <a:xfrm>
-            <a:off x="5989320" y="2377440"/>
-            <a:ext cx="548640" cy="548640"/>
-          </a:xfrm>
-          <a:prstGeom prst="ellipse">
-            <a:avLst/>
-          </a:prstGeom>
-          <a:solidFill>
-            <a:srgbClr val="0B5D46"/>
-          </a:solidFill>
-          <a:ln w="12700">
-            <a:solidFill>
-              <a:srgbClr val="0B5D46"/>
-            </a:solidFill>
-            <a:prstDash val="solid"/>
-          </a:ln>
-        </p:spPr>
-      </p:sp>
-      <p:pic>
-        <p:nvPicPr>
-          <p:cNvPr id="8" name="Image 2" descr="preencoded.png">    </p:cNvPr>
-          <p:cNvPicPr>
-            <a:picLocks noChangeAspect="1"/>
-          </p:cNvPicPr>
-          <p:nvPr/>
-        </p:nvPicPr>
-        <p:blipFill>
-          <a:blip r:embed="rId3"/>
-          <a:stretch>
-            <a:fillRect/>
-          </a:stretch>
-        </p:blipFill>
-        <p:spPr>
-          <a:xfrm>
-            <a:off x="6126480" y="2514600"/>
-            <a:ext cx="274320" cy="274320"/>
-          </a:xfrm>
-          <a:prstGeom prst="rect">
-            <a:avLst/>
-          </a:prstGeom>
-        </p:spPr>
-      </p:pic>
-      <p:sp>
-        <p:nvSpPr>
-          <p:cNvPr id="9" name="Text 4"/>
+            <a:endParaRPr lang="en-US" sz="1800" dirty="0"/>
+          </a:p>
+        </p:txBody>
+      </p:sp>
+      <p:sp>
+        <p:nvSpPr>
+          <p:cNvPr id="8" name="Text 4"/>
           <p:cNvSpPr txBox="1"/>
           <p:nvPr/>
         </p:nvSpPr>
         <p:spPr>
           <a:xfrm>
-            <a:off x="6675120" y="2377440"/>
-            <a:ext cx="2057400" cy="548640"/>
+            <a:off x="4709160" y="4247535"/>
+            <a:ext cx="3977640" cy="365760"/>
           </a:xfrm>
           <a:prstGeom prst="rect">
             <a:avLst/>
@@ -4021,109 +4962,24 @@
           <a:bodyPr wrap="square" lIns="0" tIns="0" rIns="0" bIns="0" rtlCol="0" anchor="ctr"/>
           <a:lstStyle/>
           <a:p>
-            <a:pPr indent="0" marL="0">
+            <a:pPr algn="ctr" indent="0" marL="0">
               <a:buNone/>
             </a:pPr>
             <a:r>
-              <a:rPr lang="en-US" sz="1600" b="1" dirty="0">
-                <a:solidFill>
-                  <a:srgbClr val="121417"/>
+              <a:rPr lang="en-US" sz="1800" b="1" dirty="0">
+                <a:solidFill>
+                  <a:srgbClr val="0B5D46"/>
                 </a:solidFill>
               </a:rPr>
-              <a:t>Camera stays on the iPad</a:t>
+              <a:t>Or pick a direction</a:t>
             </a:r>
-            <a:endParaRPr lang="en-US" sz="1600" dirty="0"/>
-          </a:p>
-        </p:txBody>
-      </p:sp>
-      <p:sp>
-        <p:nvSpPr>
-          <p:cNvPr id="10" name="icon LuShieldCheck"/>
-          <p:cNvSpPr/>
-          <p:nvPr/>
-        </p:nvSpPr>
-        <p:spPr>
-          <a:xfrm>
-            <a:off x="5989320" y="3246120"/>
-            <a:ext cx="548640" cy="548640"/>
-          </a:xfrm>
-          <a:prstGeom prst="ellipse">
-            <a:avLst/>
-          </a:prstGeom>
-          <a:solidFill>
-            <a:srgbClr val="0B5D46"/>
-          </a:solidFill>
-          <a:ln w="12700">
-            <a:solidFill>
-              <a:srgbClr val="0B5D46"/>
-            </a:solidFill>
-            <a:prstDash val="solid"/>
-          </a:ln>
-        </p:spPr>
-      </p:sp>
-      <p:pic>
-        <p:nvPicPr>
-          <p:cNvPr id="11" name="Image 3" descr="preencoded.png">    </p:cNvPr>
-          <p:cNvPicPr>
-            <a:picLocks noChangeAspect="1"/>
-          </p:cNvPicPr>
-          <p:nvPr/>
-        </p:nvPicPr>
-        <p:blipFill>
-          <a:blip r:embed="rId4"/>
-          <a:stretch>
-            <a:fillRect/>
-          </a:stretch>
-        </p:blipFill>
-        <p:spPr>
-          <a:xfrm>
-            <a:off x="6126480" y="3383280"/>
-            <a:ext cx="274320" cy="274320"/>
-          </a:xfrm>
-          <a:prstGeom prst="rect">
-            <a:avLst/>
-          </a:prstGeom>
-        </p:spPr>
-      </p:pic>
-      <p:sp>
-        <p:nvSpPr>
-          <p:cNvPr id="12" name="Text 6"/>
-          <p:cNvSpPr txBox="1"/>
-          <p:nvPr/>
-        </p:nvSpPr>
-        <p:spPr>
-          <a:xfrm>
-            <a:off x="6675120" y="3246120"/>
-            <a:ext cx="2057400" cy="548640"/>
-          </a:xfrm>
-          <a:prstGeom prst="rect">
-            <a:avLst/>
-          </a:prstGeom>
-          <a:noFill/>
-          <a:ln/>
-        </p:spPr>
-        <p:txBody>
-          <a:bodyPr wrap="square" lIns="0" tIns="0" rIns="0" bIns="0" rtlCol="0" anchor="ctr"/>
-          <a:lstStyle/>
-          <a:p>
-            <a:pPr indent="0" marL="0">
-              <a:buNone/>
-            </a:pPr>
-            <a:r>
-              <a:rPr lang="en-US" sz="1600" b="1" dirty="0">
-                <a:solidFill>
-                  <a:srgbClr val="121417"/>
-                </a:solidFill>
-              </a:rPr>
-              <a:t>Learns you, with permission</a:t>
-            </a:r>
-            <a:endParaRPr lang="en-US" sz="1600" dirty="0"/>
-          </a:p>
-        </p:txBody>
-      </p:sp>
-      <p:sp>
-        <p:nvSpPr>
-          <p:cNvPr id="13" name="Text 7"/>
+            <a:endParaRPr lang="en-US" sz="1800" dirty="0"/>
+          </a:p>
+        </p:txBody>
+      </p:sp>
+      <p:sp>
+        <p:nvSpPr>
+          <p:cNvPr id="9" name="Text 5"/>
           <p:cNvSpPr txBox="1"/>
           <p:nvPr/>
         </p:nvSpPr>
@@ -4151,7 +5007,7 @@
                   <a:srgbClr val="464B53"/>
                 </a:solidFill>
               </a:rPr>
-              <a:t>Camera frames stay on the iPad by design. Keys never leave the server.</a:t>
+              <a:t>Current build, iPad-size browser view, Live AI replies (wording varies run to run).</a:t>
             </a:r>
             <a:endParaRPr lang="en-US" sz="1000" dirty="0"/>
           </a:p>
@@ -4235,7 +5091,7 @@
           <p:cNvPr id="2" name="Text 0"/>
           <p:cNvSpPr/>
           <p:nvPr>
-            <p:ph idx="100" type="title" hasCustomPrompt="1"/>
+            <p:ph idx="101" type="title" hasCustomPrompt="1"/>
           </p:nvPr>
         </p:nvSpPr>
         <p:spPr>
@@ -4259,151 +5115,18 @@
             <a:r>
               <a:rPr lang="en-US" sz="3200" b="1" dirty="0">
                 <a:solidFill>
-                  <a:schemeClr val="bg1"/>
+                  <a:schemeClr val="tx1"/>
                 </a:solidFill>
               </a:rPr>
-              <a:t>Positive change, on hardware people own</a:t>
+              <a:t>Simple, private, personal</a:t>
             </a:r>
             <a:endParaRPr lang="en-US" sz="3200" dirty="0"/>
           </a:p>
         </p:txBody>
       </p:sp>
-      <p:sp>
-        <p:nvSpPr>
-          <p:cNvPr id="3" name="Text 1"/>
-          <p:cNvSpPr txBox="1"/>
-          <p:nvPr/>
-        </p:nvSpPr>
-        <p:spPr>
-          <a:xfrm>
-            <a:off x="457200" y="1234440"/>
-            <a:ext cx="3474720" cy="1097280"/>
-          </a:xfrm>
-          <a:prstGeom prst="rect">
-            <a:avLst/>
-          </a:prstGeom>
-          <a:noFill/>
-          <a:ln/>
-        </p:spPr>
-        <p:txBody>
-          <a:bodyPr wrap="square" lIns="0" tIns="0" rIns="0" bIns="0" rtlCol="0" anchor="ctr"/>
-          <a:lstStyle/>
-          <a:p>
-            <a:pPr indent="0" marL="0">
-              <a:buNone/>
-            </a:pPr>
-            <a:r>
-              <a:rPr lang="en-US" sz="8000" b="1" dirty="0">
-                <a:solidFill>
-                  <a:srgbClr val="7FD1B0"/>
-                </a:solidFill>
-              </a:rPr>
-              <a:t>3.8 s</a:t>
-            </a:r>
-            <a:endParaRPr lang="en-US" sz="8000" dirty="0"/>
-          </a:p>
-        </p:txBody>
-      </p:sp>
-      <p:sp>
-        <p:nvSpPr>
-          <p:cNvPr id="4" name="Text 2"/>
-          <p:cNvSpPr txBox="1"/>
-          <p:nvPr/>
-        </p:nvSpPr>
-        <p:spPr>
-          <a:xfrm>
-            <a:off x="457200" y="2377440"/>
-            <a:ext cx="3474720" cy="411480"/>
-          </a:xfrm>
-          <a:prstGeom prst="rect">
-            <a:avLst/>
-          </a:prstGeom>
-          <a:noFill/>
-          <a:ln/>
-        </p:spPr>
-        <p:txBody>
-          <a:bodyPr wrap="square" lIns="0" tIns="0" rIns="0" bIns="0" rtlCol="0" anchor="t"/>
-          <a:lstStyle/>
-          <a:p>
-            <a:pPr indent="0" marL="0">
-              <a:buNone/>
-            </a:pPr>
-            <a:r>
-              <a:rPr lang="en-US" sz="1800" dirty="0">
-                <a:solidFill>
-                  <a:srgbClr val="E6E8EB"/>
-                </a:solidFill>
-              </a:rPr>
-              <a:t>from partner to suggestions</a:t>
-            </a:r>
-            <a:endParaRPr lang="en-US" sz="1800" dirty="0"/>
-          </a:p>
-        </p:txBody>
-      </p:sp>
-      <p:sp>
-        <p:nvSpPr>
-          <p:cNvPr id="5" name="Text 3"/>
-          <p:cNvSpPr txBox="1"/>
-          <p:nvPr/>
-        </p:nvSpPr>
-        <p:spPr>
-          <a:xfrm>
-            <a:off x="4754880" y="1188720"/>
-            <a:ext cx="3657600" cy="365760"/>
-          </a:xfrm>
-          <a:prstGeom prst="rect">
-            <a:avLst/>
-          </a:prstGeom>
-          <a:noFill/>
-          <a:ln/>
-        </p:spPr>
-        <p:txBody>
-          <a:bodyPr wrap="square" lIns="0" tIns="0" rIns="0" bIns="0" rtlCol="0" anchor="t"/>
-          <a:lstStyle/>
-          <a:p>
-            <a:pPr indent="0" marL="0">
-              <a:buNone/>
-            </a:pPr>
-            <a:r>
-              <a:rPr lang="en-US" sz="1600" b="1" dirty="0">
-                <a:solidFill>
-                  <a:srgbClr val="9AA0A8"/>
-                </a:solidFill>
-              </a:rPr>
-              <a:t>Next</a:t>
-            </a:r>
-            <a:endParaRPr lang="en-US" sz="1600" dirty="0"/>
-          </a:p>
-        </p:txBody>
-      </p:sp>
-      <p:sp>
-        <p:nvSpPr>
-          <p:cNvPr id="6" name="icon LuUsers"/>
-          <p:cNvSpPr/>
-          <p:nvPr/>
-        </p:nvSpPr>
-        <p:spPr>
-          <a:xfrm>
-            <a:off x="4754880" y="1645920"/>
-            <a:ext cx="457200" cy="457200"/>
-          </a:xfrm>
-          <a:prstGeom prst="ellipse">
-            <a:avLst/>
-          </a:prstGeom>
-          <a:solidFill>
-            <a:srgbClr val="E2F2EC"/>
-          </a:solidFill>
-          <a:ln w="12700">
-            <a:solidFill>
-              <a:srgbClr val="E2F2EC"/>
-            </a:solidFill>
-            <a:prstDash val="solid"/>
-          </a:ln>
-        </p:spPr>
-      </p:sp>
       <p:pic>
         <p:nvPicPr>
-          <p:cNvPr id="7" name="Image 0" descr="preencoded.png">    </p:cNvPr>
+          <p:cNvPr id="3" name="Image 0" descr="Simplified architecture: iPad (camera, microphone, speaker), our Railway server, OpenAI and ElevenLabs">    </p:cNvPr>
           <p:cNvPicPr>
             <a:picLocks noChangeAspect="1"/>
           </p:cNvPicPr>
@@ -4417,8 +5140,8 @@
         </p:blipFill>
         <p:spPr>
           <a:xfrm>
-            <a:off x="4869180" y="1760220"/>
-            <a:ext cx="228600" cy="228600"/>
+            <a:off x="365760" y="1097280"/>
+            <a:ext cx="5303520" cy="2430780"/>
           </a:xfrm>
           <a:prstGeom prst="rect">
             <a:avLst/>
@@ -4427,60 +5150,24 @@
       </p:pic>
       <p:sp>
         <p:nvSpPr>
-          <p:cNvPr id="8" name="Text 5"/>
-          <p:cNvSpPr txBox="1"/>
-          <p:nvPr/>
-        </p:nvSpPr>
-        <p:spPr>
-          <a:xfrm>
-            <a:off x="5394960" y="1645920"/>
-            <a:ext cx="3291840" cy="457200"/>
-          </a:xfrm>
-          <a:prstGeom prst="rect">
-            <a:avLst/>
-          </a:prstGeom>
-          <a:noFill/>
-          <a:ln/>
-        </p:spPr>
-        <p:txBody>
-          <a:bodyPr wrap="square" lIns="0" tIns="0" rIns="0" bIns="0" rtlCol="0" anchor="ctr"/>
-          <a:lstStyle/>
-          <a:p>
-            <a:pPr indent="0" marL="0">
-              <a:buNone/>
-            </a:pPr>
-            <a:r>
-              <a:rPr lang="en-US" sz="1800" b="1" dirty="0">
-                <a:solidFill>
-                  <a:srgbClr val="FFFFFF"/>
-                </a:solidFill>
-              </a:rPr>
-              <a:t>Test with people with ALS</a:t>
-            </a:r>
-            <a:endParaRPr lang="en-US" sz="1800" dirty="0"/>
-          </a:p>
-        </p:txBody>
-      </p:sp>
-      <p:sp>
-        <p:nvSpPr>
-          <p:cNvPr id="9" name="icon LuSmartphone"/>
+          <p:cNvPr id="4" name="icon LuScanFace"/>
           <p:cNvSpPr/>
           <p:nvPr/>
         </p:nvSpPr>
         <p:spPr>
           <a:xfrm>
-            <a:off x="4754880" y="2267712"/>
-            <a:ext cx="457200" cy="457200"/>
+            <a:off x="5989320" y="1234440"/>
+            <a:ext cx="548640" cy="548640"/>
           </a:xfrm>
           <a:prstGeom prst="ellipse">
             <a:avLst/>
           </a:prstGeom>
           <a:solidFill>
-            <a:srgbClr val="E2F2EC"/>
+            <a:srgbClr val="0B5D46"/>
           </a:solidFill>
           <a:ln w="12700">
             <a:solidFill>
-              <a:srgbClr val="E2F2EC"/>
+              <a:srgbClr val="0B5D46"/>
             </a:solidFill>
             <a:prstDash val="solid"/>
           </a:ln>
@@ -4488,7 +5175,7 @@
       </p:sp>
       <p:pic>
         <p:nvPicPr>
-          <p:cNvPr id="10" name="Image 1" descr="preencoded.png">    </p:cNvPr>
+          <p:cNvPr id="5" name="Image 1" descr="preencoded.png">    </p:cNvPr>
           <p:cNvPicPr>
             <a:picLocks noChangeAspect="1"/>
           </p:cNvPicPr>
@@ -4502,8 +5189,8 @@
         </p:blipFill>
         <p:spPr>
           <a:xfrm>
-            <a:off x="4869180" y="2382012"/>
-            <a:ext cx="228600" cy="228600"/>
+            <a:off x="6126480" y="1371600"/>
+            <a:ext cx="274320" cy="274320"/>
           </a:xfrm>
           <a:prstGeom prst="rect">
             <a:avLst/>
@@ -4512,14 +5199,14 @@
       </p:pic>
       <p:sp>
         <p:nvSpPr>
-          <p:cNvPr id="11" name="Text 7"/>
+          <p:cNvPr id="6" name="Text 2"/>
           <p:cNvSpPr txBox="1"/>
           <p:nvPr/>
         </p:nvSpPr>
         <p:spPr>
           <a:xfrm>
-            <a:off x="5394960" y="2267712"/>
-            <a:ext cx="3291840" cy="457200"/>
+            <a:off x="6675120" y="1234440"/>
+            <a:ext cx="2057400" cy="548640"/>
           </a:xfrm>
           <a:prstGeom prst="rect">
             <a:avLst/>
@@ -4535,37 +5222,37 @@
               <a:buNone/>
             </a:pPr>
             <a:r>
-              <a:rPr lang="en-US" sz="1800" b="1" dirty="0">
-                <a:solidFill>
-                  <a:srgbClr val="FFFFFF"/>
+              <a:rPr lang="en-US" sz="1600" b="1" dirty="0">
+                <a:solidFill>
+                  <a:srgbClr val="121417"/>
                 </a:solidFill>
               </a:rPr>
-              <a:t>Phones and offline</a:t>
+              <a:t>Calibrated to your face</a:t>
             </a:r>
-            <a:endParaRPr lang="en-US" sz="1800" dirty="0"/>
-          </a:p>
-        </p:txBody>
-      </p:sp>
-      <p:sp>
-        <p:nvSpPr>
-          <p:cNvPr id="12" name="icon LuAudioLines"/>
+            <a:endParaRPr lang="en-US" sz="1600" dirty="0"/>
+          </a:p>
+        </p:txBody>
+      </p:sp>
+      <p:sp>
+        <p:nvSpPr>
+          <p:cNvPr id="7" name="icon LuLock"/>
           <p:cNvSpPr/>
           <p:nvPr/>
         </p:nvSpPr>
         <p:spPr>
           <a:xfrm>
-            <a:off x="4754880" y="2889504"/>
-            <a:ext cx="457200" cy="457200"/>
+            <a:off x="5989320" y="2011680"/>
+            <a:ext cx="548640" cy="548640"/>
           </a:xfrm>
           <a:prstGeom prst="ellipse">
             <a:avLst/>
           </a:prstGeom>
           <a:solidFill>
-            <a:srgbClr val="E2F2EC"/>
+            <a:srgbClr val="0B5D46"/>
           </a:solidFill>
           <a:ln w="12700">
             <a:solidFill>
-              <a:srgbClr val="E2F2EC"/>
+              <a:srgbClr val="0B5D46"/>
             </a:solidFill>
             <a:prstDash val="solid"/>
           </a:ln>
@@ -4573,7 +5260,7 @@
       </p:sp>
       <p:pic>
         <p:nvPicPr>
-          <p:cNvPr id="13" name="Image 2" descr="preencoded.png">    </p:cNvPr>
+          <p:cNvPr id="8" name="Image 2" descr="preencoded.png">    </p:cNvPr>
           <p:cNvPicPr>
             <a:picLocks noChangeAspect="1"/>
           </p:cNvPicPr>
@@ -4587,8 +5274,8 @@
         </p:blipFill>
         <p:spPr>
           <a:xfrm>
-            <a:off x="4869180" y="3003804"/>
-            <a:ext cx="228600" cy="228600"/>
+            <a:off x="6126480" y="2148840"/>
+            <a:ext cx="274320" cy="274320"/>
           </a:xfrm>
           <a:prstGeom prst="rect">
             <a:avLst/>
@@ -4597,14 +5284,14 @@
       </p:pic>
       <p:sp>
         <p:nvSpPr>
-          <p:cNvPr id="14" name="Text 9"/>
+          <p:cNvPr id="9" name="Text 4"/>
           <p:cNvSpPr txBox="1"/>
           <p:nvPr/>
         </p:nvSpPr>
         <p:spPr>
           <a:xfrm>
-            <a:off x="5394960" y="2889504"/>
-            <a:ext cx="3291840" cy="457200"/>
+            <a:off x="6675120" y="2011680"/>
+            <a:ext cx="2057400" cy="548640"/>
           </a:xfrm>
           <a:prstGeom prst="rect">
             <a:avLst/>
@@ -4620,20 +5307,45 @@
               <a:buNone/>
             </a:pPr>
             <a:r>
-              <a:rPr lang="en-US" sz="1800" b="1" dirty="0">
-                <a:solidFill>
-                  <a:srgbClr val="FFFFFF"/>
+              <a:rPr lang="en-US" sz="1600" b="1" dirty="0">
+                <a:solidFill>
+                  <a:srgbClr val="121417"/>
                 </a:solidFill>
               </a:rPr>
-              <a:t>Personal voice</a:t>
+              <a:t>Camera stays on the iPad</a:t>
             </a:r>
-            <a:endParaRPr lang="en-US" sz="1800" dirty="0"/>
-          </a:p>
-        </p:txBody>
+            <a:endParaRPr lang="en-US" sz="1600" dirty="0"/>
+          </a:p>
+        </p:txBody>
+      </p:sp>
+      <p:sp>
+        <p:nvSpPr>
+          <p:cNvPr id="10" name="icon LuShieldCheck"/>
+          <p:cNvSpPr/>
+          <p:nvPr/>
+        </p:nvSpPr>
+        <p:spPr>
+          <a:xfrm>
+            <a:off x="5989320" y="2788920"/>
+            <a:ext cx="548640" cy="548640"/>
+          </a:xfrm>
+          <a:prstGeom prst="ellipse">
+            <a:avLst/>
+          </a:prstGeom>
+          <a:solidFill>
+            <a:srgbClr val="0B5D46"/>
+          </a:solidFill>
+          <a:ln w="12700">
+            <a:solidFill>
+              <a:srgbClr val="0B5D46"/>
+            </a:solidFill>
+            <a:prstDash val="solid"/>
+          </a:ln>
+        </p:spPr>
       </p:sp>
       <p:pic>
         <p:nvPicPr>
-          <p:cNvPr id="15" name="Image 3" descr="Still Here mark">    </p:cNvPr>
+          <p:cNvPr id="11" name="Image 3" descr="preencoded.png">    </p:cNvPr>
           <p:cNvPicPr>
             <a:picLocks noChangeAspect="1"/>
           </p:cNvPicPr>
@@ -4647,8 +5359,8 @@
         </p:blipFill>
         <p:spPr>
           <a:xfrm>
-            <a:off x="457200" y="3675888"/>
-            <a:ext cx="457200" cy="457200"/>
+            <a:off x="6126480" y="2926080"/>
+            <a:ext cx="274320" cy="274320"/>
           </a:xfrm>
           <a:prstGeom prst="rect">
             <a:avLst/>
@@ -4657,14 +5369,14 @@
       </p:pic>
       <p:sp>
         <p:nvSpPr>
-          <p:cNvPr id="16" name="Text 10"/>
+          <p:cNvPr id="12" name="Text 6"/>
           <p:cNvSpPr txBox="1"/>
           <p:nvPr/>
         </p:nvSpPr>
         <p:spPr>
           <a:xfrm>
-            <a:off x="1051560" y="3630168"/>
-            <a:ext cx="5029200" cy="548640"/>
+            <a:off x="6675120" y="2788920"/>
+            <a:ext cx="2057400" cy="548640"/>
           </a:xfrm>
           <a:prstGeom prst="rect">
             <a:avLst/>
@@ -4680,27 +5392,74 @@
               <a:buNone/>
             </a:pPr>
             <a:r>
-              <a:rPr lang="en-US" sz="3000" b="1" dirty="0">
-                <a:solidFill>
-                  <a:srgbClr val="7FD1B0"/>
+              <a:rPr lang="en-US" sz="1600" b="1" dirty="0">
+                <a:solidFill>
+                  <a:srgbClr val="121417"/>
                 </a:solidFill>
               </a:rPr>
-              <a:t>Your words. Your choice.</a:t>
+              <a:t>Learns you, with permission</a:t>
             </a:r>
-            <a:endParaRPr lang="en-US" sz="3000" dirty="0"/>
-          </a:p>
-        </p:txBody>
-      </p:sp>
-      <p:sp>
-        <p:nvSpPr>
-          <p:cNvPr id="17" name="Text 11"/>
+            <a:endParaRPr lang="en-US" sz="1600" dirty="0"/>
+          </a:p>
+        </p:txBody>
+      </p:sp>
+      <p:sp>
+        <p:nvSpPr>
+          <p:cNvPr id="13" name="Shape 7"/>
+          <p:cNvSpPr/>
+          <p:nvPr/>
+        </p:nvSpPr>
+        <p:spPr>
+          <a:xfrm>
+            <a:off x="457200" y="3730752"/>
+            <a:ext cx="8229600" cy="0"/>
+          </a:xfrm>
+          <a:prstGeom prst="line">
+            <a:avLst/>
+          </a:prstGeom>
+          <a:noFill/>
+          <a:ln w="9525">
+            <a:solidFill>
+              <a:srgbClr val="D9DCE0"/>
+            </a:solidFill>
+            <a:prstDash val="solid"/>
+          </a:ln>
+        </p:spPr>
+      </p:sp>
+      <p:pic>
+        <p:nvPicPr>
+          <p:cNvPr id="14" name="Image 4" descr="Still Here mark">    </p:cNvPr>
+          <p:cNvPicPr>
+            <a:picLocks noChangeAspect="1"/>
+          </p:cNvPicPr>
+          <p:nvPr/>
+        </p:nvPicPr>
+        <p:blipFill>
+          <a:blip r:embed="rId5"/>
+          <a:stretch>
+            <a:fillRect/>
+          </a:stretch>
+        </p:blipFill>
+        <p:spPr>
+          <a:xfrm>
+            <a:off x="457200" y="3858768"/>
+            <a:ext cx="420624" cy="420624"/>
+          </a:xfrm>
+          <a:prstGeom prst="rect">
+            <a:avLst/>
+          </a:prstGeom>
+        </p:spPr>
+      </p:pic>
+      <p:sp>
+        <p:nvSpPr>
+          <p:cNvPr id="15" name="Text 8"/>
           <p:cNvSpPr txBox="1"/>
           <p:nvPr/>
         </p:nvSpPr>
         <p:spPr>
           <a:xfrm>
-            <a:off x="457200" y="4754880"/>
-            <a:ext cx="7406640" cy="256032"/>
+            <a:off x="1005840" y="3813048"/>
+            <a:ext cx="5486400" cy="512064"/>
           </a:xfrm>
           <a:prstGeom prst="rect">
             <a:avLst/>
@@ -4716,14 +5475,50 @@
               <a:buNone/>
             </a:pPr>
             <a:r>
-              <a:rPr lang="en-US" sz="1000" dirty="0">
-                <a:solidFill>
-                  <a:srgbClr val="9AA0A8"/>
+              <a:rPr lang="en-US" sz="2600" b="1" dirty="0">
+                <a:solidFill>
+                  <a:srgbClr val="0B5D46"/>
                 </a:solidFill>
               </a:rPr>
-              <a:t>3.8 s: median, Mac to deployed server, synthetic speech.</a:t>
+              <a:t>Your words. Your choice.</a:t>
             </a:r>
-            <a:endParaRPr lang="en-US" sz="1000" dirty="0"/>
+            <a:endParaRPr lang="en-US" sz="2600" dirty="0"/>
+          </a:p>
+        </p:txBody>
+      </p:sp>
+      <p:sp>
+        <p:nvSpPr>
+          <p:cNvPr id="16" name="Text 9"/>
+          <p:cNvSpPr txBox="1"/>
+          <p:nvPr/>
+        </p:nvSpPr>
+        <p:spPr>
+          <a:xfrm>
+            <a:off x="1005840" y="4370832"/>
+            <a:ext cx="6766560" cy="292608"/>
+          </a:xfrm>
+          <a:prstGeom prst="rect">
+            <a:avLst/>
+          </a:prstGeom>
+          <a:noFill/>
+          <a:ln/>
+        </p:spPr>
+        <p:txBody>
+          <a:bodyPr wrap="square" lIns="0" tIns="0" rIns="0" bIns="0" rtlCol="0" anchor="ctr"/>
+          <a:lstStyle/>
+          <a:p>
+            <a:pPr indent="0" marL="0">
+              <a:buNone/>
+            </a:pPr>
+            <a:r>
+              <a:rPr lang="en-US" sz="1300" dirty="0">
+                <a:solidFill>
+                  <a:srgbClr val="464B53"/>
+                </a:solidFill>
+              </a:rPr>
+              <a:t>Next: test with people with ALS · phones and offline · personal voice</a:t>
+            </a:r>
+            <a:endParaRPr lang="en-US" sz="1300" dirty="0"/>
           </a:p>
         </p:txBody>
       </p:sp>

</xml_diff>

<commit_message>
Deck: generalize to any phone or tablet
Co-Authored-By: Claude Opus 5.5 <noreply@anthropic.com>
</commit_message>
<xml_diff>
--- a/docs/deck/final/Still_Here_6.pptx
+++ b/docs/deck/final/Still_Here_6.pptx
@@ -112,7 +112,7 @@
   <p:extLst>
     <p:ext uri="{521415D9-36F7-43E2-AB2F-B90AF26B5E84}">
       <p14:sectionLst xmlns:p14="http://schemas.microsoft.com/office/powerpoint/2010/main">
-        <p14:section name="Pitch" id="{41d728f4-7ff8-94bf-d7d4-2fc6fc28df96}">
+        <p14:section name="Pitch" id="{c1c2d7cf-3be9-ff90-6006-dc553794e4f1}">
           <p14:sldIdLst>
             <p14:sldId id="256"/>
             <p14:sldId id="257"/>
@@ -702,7 +702,7 @@
           <a:p>
             <a:r>
               <a:rPr lang="en-US" dirty="0"/>
-              <a:t>Still Here listens when the partner talks and suggests the two best replies, plus other ways to answer. The person raises their eyebrows to move and does a long blink to choose. The chosen reply is spoken in a natural voice, on a regular iPad with no eye tracker or special hardware.</a:t>
+              <a:t>Still Here listens when the partner talks and suggests the two best replies, plus other ways to answer. The person raises their eyebrows to move and does a long blink to choose. The chosen reply is spoken in a natural voice, on an everyday phone or tablet with a front camera, no eye tracker or special hardware. Today we've tested it on an iPad; phones are next.</a:t>
             </a:r>
             <a:endParaRPr lang="en-US" dirty="0"/>
           </a:p>
@@ -3699,7 +3699,7 @@
       </p:sp>
       <p:pic>
         <p:nvPicPr>
-          <p:cNvPr id="26" name="Image 4" descr="iPad">    </p:cNvPr>
+          <p:cNvPr id="26" name="Image 4" descr="Phone or tablet">    </p:cNvPr>
           <p:cNvPicPr>
             <a:picLocks noChangeAspect="1"/>
           </p:cNvPicPr>
@@ -3713,7 +3713,7 @@
         </p:blipFill>
         <p:spPr>
           <a:xfrm>
-            <a:off x="2240280" y="3822192"/>
+            <a:off x="1600200" y="3822192"/>
             <a:ext cx="457200" cy="457200"/>
           </a:xfrm>
           <a:prstGeom prst="rect">
@@ -3729,8 +3729,8 @@
         </p:nvSpPr>
         <p:spPr>
           <a:xfrm>
-            <a:off x="2788920" y="3794760"/>
-            <a:ext cx="4572000" cy="502920"/>
+            <a:off x="2148840" y="3794760"/>
+            <a:ext cx="5669280" cy="502920"/>
           </a:xfrm>
           <a:prstGeom prst="rect">
             <a:avLst/>
@@ -3751,7 +3751,7 @@
                   <a:srgbClr val="0B5D46"/>
                 </a:solidFill>
               </a:rPr>
-              <a:t>Just an iPad. No special hardware.</a:t>
+              <a:t>Any phone or tablet. No special hardware.</a:t>
             </a:r>
             <a:endParaRPr lang="en-US" sz="2400" dirty="0"/>
           </a:p>

</xml_diff>

<commit_message>
Fix spelling: Richard Oghenefejiro
Co-Authored-By: Claude Opus 5.5 <noreply@anthropic.com>
</commit_message>
<xml_diff>
--- a/docs/deck/final/Still_Here_6.pptx
+++ b/docs/deck/final/Still_Here_6.pptx
@@ -112,7 +112,7 @@
   <p:extLst>
     <p:ext uri="{521415D9-36F7-43E2-AB2F-B90AF26B5E84}">
       <p14:sectionLst xmlns:p14="http://schemas.microsoft.com/office/powerpoint/2010/main">
-        <p14:section name="Pitch" id="{c1c2d7cf-3be9-ff90-6006-dc553794e4f1}">
+        <p14:section name="Pitch" id="{cb73077d-1742-4041-bc89-8d728cebdc69}">
           <p14:sldIdLst>
             <p14:sldId id="256"/>
             <p14:sldId id="257"/>
@@ -2049,7 +2049,7 @@
                   <a:srgbClr val="9AA0A8"/>
                 </a:solidFill>
               </a:rPr>
-              <a:t>Liam Howeth  ·  Richard Ognefijiro  ·  SASEHacks for Good</a:t>
+              <a:t>Liam Howeth  ·  Richard Oghenefejiro  ·  SASEHacks for Good</a:t>
             </a:r>
             <a:endParaRPr lang="en-US" sz="1200" dirty="0"/>
           </a:p>

</xml_diff>

<commit_message>
Team name: Richard Oduma
Co-Authored-By: Claude Opus 5.5 <noreply@anthropic.com>
</commit_message>
<xml_diff>
--- a/docs/deck/final/Still_Here_6.pptx
+++ b/docs/deck/final/Still_Here_6.pptx
@@ -112,7 +112,7 @@
   <p:extLst>
     <p:ext uri="{521415D9-36F7-43E2-AB2F-B90AF26B5E84}">
       <p14:sectionLst xmlns:p14="http://schemas.microsoft.com/office/powerpoint/2010/main">
-        <p14:section name="Pitch" id="{cb73077d-1742-4041-bc89-8d728cebdc69}">
+        <p14:section name="Pitch" id="{f07c3953-673c-a07b-9b23-aaa6670d33d5}">
           <p14:sldIdLst>
             <p14:sldId id="256"/>
             <p14:sldId id="257"/>
@@ -2049,7 +2049,7 @@
                   <a:srgbClr val="9AA0A8"/>
                 </a:solidFill>
               </a:rPr>
-              <a:t>Liam Howeth  ·  Richard Oghenefejiro  ·  SASEHacks for Good</a:t>
+              <a:t>Liam Howeth  ·  Richard Oduma  ·  SASEHacks for Good</a:t>
             </a:r>
             <a:endParaRPr lang="en-US" sz="1200" dirty="0"/>
           </a:p>

</xml_diff>